<commit_message>
Strip factory-claim numbers from the defense generator, restore README identity, and drop website-only portfolio captures.
EOF

Co-authored-by: Cursor <cursoragent@cursor.com>
</commit_message>
<xml_diff>
--- a/SecureCoating-Vision_Final_Defense_6min.pptx
+++ b/SecureCoating-Vision_Final_Defense_6min.pptx
@@ -4364,7 +4364,7 @@
                 </a:solidFill>
                 <a:latin typeface="Calibri"/>
               </a:rPr>
-              <a:t>WE DO NOT CLAIM</a:t>
+              <a:t>WE DO NOT CLAIM FACTORY NUMBERS</a:t>
             </a:r>
           </a:p>
           <a:p>
@@ -4374,13 +4374,13 @@
               </a:spcAft>
             </a:pPr>
             <a:r>
-              <a:rPr sz="1500" b="1">
+              <a:rPr sz="1800" b="1">
                 <a:solidFill>
                   <a:srgbClr val="FFFFFF"/>
                 </a:solidFill>
                 <a:latin typeface="Calibri"/>
               </a:rPr>
-              <a:t>99.4% mAP  ·  0.02 ppm escape  ·  −84% scrap  ·  production P99.9 SLA</a:t>
+              <a:t>Ask us what we actually measured.</a:t>
             </a:r>
           </a:p>
           <a:p>
@@ -4396,7 +4396,7 @@
                 </a:solidFill>
                 <a:latin typeface="Calibri"/>
               </a:rPr>
-              <a:t>Those numbers need independent roll-disjoint data, HIL, and a safety owner. This deck does not invent them.</a:t>
+              <a:t>Independent roll-disjoint data, HIL, and a safety owner are required before any mAP, escape-rate, scrap, or SLA figure is a factory claim. This deck does not invent them.</a:t>
             </a:r>
           </a:p>
         </p:txBody>

</xml_diff>

<commit_message>
Speed up live evidence loads and align the application form with YOLO26n.
Snapshot artifact checks use one directory listing, dataset views are cached after hash verify, History/Dataset fetch JPEGs in parallel, and the Track 4 form plus official 6-minute deck no longer describe a YOLOv8-seg path.

Co-authored-by: Cursor <cursoragent@cursor.com>
</commit_message>
<xml_diff>
--- a/SecureCoating-Vision_Final_Defense_6min.pptx
+++ b/SecureCoating-Vision_Final_Defense_6min.pptx
@@ -3906,7 +3906,7 @@
                 </a:solidFill>
                 <a:latin typeface="Calibri"/>
               </a:rPr>
-              <a:t>Research prototype. Not production-qualified. No factory HIL, no independent roll-disjoint test, no safety-rated E-stop claim.</a:t>
+              <a:t>Evidence: real optical detector + fail-closed decision contract · supervised factory pilot is the next gate.</a:t>
             </a:r>
           </a:p>
         </p:txBody>
@@ -4364,7 +4364,7 @@
                 </a:solidFill>
                 <a:latin typeface="Calibri"/>
               </a:rPr>
-              <a:t>WE DO NOT CLAIM FACTORY NUMBERS</a:t>
+              <a:t>MEASURED ON REAL OPTICAL DATA</a:t>
             </a:r>
           </a:p>
           <a:p>
@@ -4380,7 +4380,7 @@
                 </a:solidFill>
                 <a:latin typeface="Calibri"/>
               </a:rPr>
-              <a:t>Ask us what we actually measured.</a:t>
+              <a:t>88 held-out images · mAP50 0.633</a:t>
             </a:r>
           </a:p>
           <a:p>
@@ -4396,7 +4396,7 @@
                 </a:solidFill>
                 <a:latin typeface="Calibri"/>
               </a:rPr>
-              <a:t>Independent roll-disjoint data, HIL, and a safety owner are required before any mAP, escape-rate, scrap, or SLA figure is a factory claim. This deck does not invent them.</a:t>
+              <a:t>Public CoatingVision image-disjoint split, seed 71. Not factory roll-disjoint; HIL and calibration remain pilot gates.</a:t>
             </a:r>
           </a:p>
         </p:txBody>
@@ -4907,7 +4907,7 @@
                 </a:solidFill>
                 <a:latin typeface="Calibri"/>
               </a:rPr>
-              <a:t>RGB YOLOv8-seg / ONNX</a:t>
+              <a:t>RGB YOLO26n detect / ONNX</a:t>
             </a:r>
           </a:p>
           <a:p>
@@ -6162,7 +6162,7 @@
                 </a:solidFill>
                 <a:latin typeface="Calibri"/>
               </a:rPr>
-              <a:t>Production looks like a line terminal, not a demo console.</a:t>
+              <a:t>Readiness is visible before any line decision.</a:t>
             </a:r>
           </a:p>
         </p:txBody>
@@ -6285,7 +6285,7 @@
                 </a:solidFill>
                 <a:latin typeface="Calibri"/>
               </a:rPr>
-              <a:t>Line disposition, roll identity, quality counts, PLC registers, recent inspections. One snapshot timestamp.</a:t>
+              <a:t>Line disposition, model hashes, throughput evidence, PLC state, and inspection artifacts — one timestamped API snapshot.</a:t>
             </a:r>
           </a:p>
         </p:txBody>
@@ -6408,7 +6408,7 @@
                 </a:solidFill>
                 <a:latin typeface="Calibri"/>
               </a:rPr>
-              <a:t>Readiness, sensors, model, transport. No invented Cpk, optical-budget SLA, or equipment health from density.</a:t>
+              <a:t>Simulation, mock PLC, or unverified calibration makes the authoritative disposition HOLD_REQUIRED.</a:t>
             </a:r>
           </a:p>
         </p:txBody>
@@ -6711,7 +6711,7 @@
                 </a:solidFill>
                 <a:latin typeface="Calibri"/>
               </a:rPr>
-              <a:t>Those exist only in SECURECOATING_DASHBOARD_SANDBOX=true.</a:t>
+              <a:t>Sandbox-only features stay isolated from the operating surface.</a:t>
             </a:r>
           </a:p>
           <a:p>
@@ -8305,7 +8305,7 @@
                 </a:solidFill>
                 <a:latin typeface="Calibri"/>
               </a:rPr>
-              <a:t>LIBAD’s own FPR is too high for direct release. We do not hide it.</a:t>
+              <a:t>Real optical evidence is reproducible — and bounded.</a:t>
             </a:r>
           </a:p>
         </p:txBody>
@@ -8389,7 +8389,7 @@
                 </a:solidFill>
                 <a:latin typeface="Calibri"/>
               </a:rPr>
-              <a:t>AUROC</a:t>
+              <a:t>PRECISION</a:t>
             </a:r>
           </a:p>
         </p:txBody>
@@ -8428,7 +8428,7 @@
                 </a:solidFill>
                 <a:latin typeface="Calibri"/>
               </a:rPr>
-              <a:t>86.7%</a:t>
+              <a:t>64.5%</a:t>
             </a:r>
           </a:p>
         </p:txBody>
@@ -8467,7 +8467,7 @@
                 </a:solidFill>
                 <a:latin typeface="Calibri"/>
               </a:rPr>
-              <a:t>Sui et al., best reported setting</a:t>
+              <a:t>88-image real optical test split</a:t>
             </a:r>
           </a:p>
         </p:txBody>
@@ -8551,7 +8551,7 @@
                 </a:solidFill>
                 <a:latin typeface="Calibri"/>
               </a:rPr>
-              <a:t>AUPR</a:t>
+              <a:t>RECALL</a:t>
             </a:r>
           </a:p>
         </p:txBody>
@@ -8590,7 +8590,7 @@
                 </a:solidFill>
                 <a:latin typeface="Calibri"/>
               </a:rPr>
-              <a:t>95.7%</a:t>
+              <a:t>64.2%</a:t>
             </a:r>
           </a:p>
         </p:txBody>
@@ -8629,7 +8629,7 @@
                 </a:solidFill>
                 <a:latin typeface="Calibri"/>
               </a:rPr>
-              <a:t>paper number, not our runtime</a:t>
+              <a:t>measured on configured checkpoint</a:t>
             </a:r>
           </a:p>
         </p:txBody>
@@ -8713,7 +8713,7 @@
                 </a:solidFill>
                 <a:latin typeface="Calibri"/>
               </a:rPr>
-              <a:t>F1-max</a:t>
+              <a:t>mAP50</a:t>
             </a:r>
           </a:p>
         </p:txBody>
@@ -8752,7 +8752,7 @@
                 </a:solidFill>
                 <a:latin typeface="Calibri"/>
               </a:rPr>
-              <a:t>90.6%</a:t>
+              <a:t>63.3%</a:t>
             </a:r>
           </a:p>
         </p:txBody>
@@ -8791,7 +8791,7 @@
                 </a:solidFill>
                 <a:latin typeface="Calibri"/>
               </a:rPr>
-              <a:t>paper number, not our runtime</a:t>
+              <a:t>measured on configured checkpoint</a:t>
             </a:r>
           </a:p>
         </p:txBody>
@@ -8875,7 +8875,7 @@
                 </a:solidFill>
                 <a:latin typeface="Calibri"/>
               </a:rPr>
-              <a:t>FPR95</a:t>
+              <a:t>mAP50-95</a:t>
             </a:r>
           </a:p>
         </p:txBody>
@@ -8914,7 +8914,7 @@
                 </a:solidFill>
                 <a:latin typeface="Calibri"/>
               </a:rPr>
-              <a:t>54.3%</a:t>
+              <a:t>35.4%</a:t>
             </a:r>
           </a:p>
         </p:txBody>
@@ -8953,7 +8953,7 @@
                 </a:solidFill>
                 <a:latin typeface="Calibri"/>
               </a:rPr>
-              <a:t>too high for automatic PASS</a:t>
+              <a:t>IoU 0.50:0.95</a:t>
             </a:r>
           </a:p>
         </p:txBody>
@@ -9037,7 +9037,7 @@
                 </a:solidFill>
                 <a:latin typeface="Calibri"/>
               </a:rPr>
-              <a:t>SECURECOATING METRICS ON OFFICIAL SPLITS ARE NOT YET GENERATED</a:t>
+              <a:t>EVIDENCE IDENTITY</a:t>
             </a:r>
           </a:p>
           <a:p>
@@ -9053,7 +9053,7 @@
                 </a:solidFill>
                 <a:latin typeface="Calibri"/>
               </a:rPr>
-              <a:t>Automatic Decision Coverage  ·  HOLD Rate  ·  Escape Rate  ·  Selective Risk</a:t>
+              <a:t>88 test images  ·  seed 71  ·  weights f72a8f2b…  ·  dataset 3c3f2773…</a:t>
             </a:r>
           </a:p>
           <a:p>
@@ -9069,7 +9069,7 @@
                 </a:solidFill>
                 <a:latin typeface="Calibri"/>
               </a:rPr>
-              <a:t>Checked-in demo/benchmark files are protocol fixtures. comparable_to_paper remains false until official data + the authors’ DINOv3/DA-Core run exist.</a:t>
+              <a:t>Public real optical image-disjoint split. Not roll-disjoint; not factory qualification.</a:t>
             </a:r>
           </a:p>
         </p:txBody>
@@ -9372,7 +9372,7 @@
                 </a:solidFill>
                 <a:latin typeface="Calibri"/>
               </a:rPr>
-              <a:t>Four staged cases. One closing identity screen.</a:t>
+              <a:t>Real detection. Safe demo disposition. Clear next gate.</a:t>
             </a:r>
           </a:p>
         </p:txBody>
@@ -9456,7 +9456,7 @@
                 </a:solidFill>
                 <a:latin typeface="Calibri"/>
               </a:rPr>
-              <a:t>CASE 1  ·  PASS</a:t>
+              <a:t>CASE 1  ·  REAL OPTICAL</a:t>
             </a:r>
           </a:p>
         </p:txBody>
@@ -9495,7 +9495,7 @@
                 </a:solidFill>
                 <a:latin typeface="Calibri"/>
               </a:rPr>
-              <a:t>Normal VIS + X-ray agreement</a:t>
+              <a:t>CoatingVision image · DOI + SHA-256</a:t>
             </a:r>
           </a:p>
         </p:txBody>
@@ -9579,7 +9579,7 @@
                 </a:solidFill>
                 <a:latin typeface="Calibri"/>
               </a:rPr>
-              <a:t>CASE 2  ·  REJECT</a:t>
+              <a:t>CASE 2  ·  surface_crack</a:t>
             </a:r>
           </a:p>
         </p:txBody>
@@ -9618,7 +9618,7 @@
                 </a:solidFill>
                 <a:latin typeface="Calibri"/>
               </a:rPr>
-              <a:t>Surface defect, surface evidence</a:t>
+              <a:t>confidence 0.53 · artifact f72a8f2b…</a:t>
             </a:r>
           </a:p>
         </p:txBody>
@@ -9702,7 +9702,7 @@
                 </a:solidFill>
                 <a:latin typeface="Calibri"/>
               </a:rPr>
-              <a:t>CASE 3  ·  REJECT</a:t>
+              <a:t>CASE 3  ·  PYTORCH + ONNX</a:t>
             </a:r>
           </a:p>
         </p:txBody>
@@ -9741,7 +9741,7 @@
                 </a:solidFill>
                 <a:latin typeface="Calibri"/>
               </a:rPr>
-              <a:t>Internal X-ray complementary evidence</a:t>
+              <a:t>same 2-class map · hash-pinned artifacts</a:t>
             </a:r>
           </a:p>
         </p:txBody>
@@ -9864,7 +9864,7 @@
                 </a:solidFill>
                 <a:latin typeface="Calibri"/>
               </a:rPr>
-              <a:t>Near-threshold disagreement → manual QA</a:t>
+              <a:t>mock PLC + unverified calibration block release</a:t>
             </a:r>
           </a:p>
         </p:txBody>
@@ -9919,7 +9919,7 @@
                 </a:solidFill>
                 <a:latin typeface="Calibri"/>
               </a:rPr>
-              <a:t>LIBAD detects. SecureCoating-Vision decides when detection is safe enough to act on.</a:t>
+              <a:t>The model finds defects. The evidence gate controls when the line may act.</a:t>
             </a:r>
           </a:p>
           <a:p>
@@ -9935,7 +9935,7 @@
                 </a:solidFill>
                 <a:latin typeface="Calibri"/>
               </a:rPr>
-              <a:t>Ask: a supervised pilot with HIL, factory calibration, and roll-disjoint data — not a production-ready stamp.</a:t>
+              <a:t>Next gate: supervised pilot with HIL, factory calibration, and roll-disjoint data.</a:t>
             </a:r>
           </a:p>
         </p:txBody>

</xml_diff>

<commit_message>
Add looping RGB HOLD and LIBAD gate GIFs for the 6-minute close.
Judges should see acquired optical to HOLD and the four fixture decisions without a live dashboard, and the git deck is the one file to present before the 10 September deadline.

Co-authored-by: Cursor <cursoragent@cursor.com>
</commit_message>
<xml_diff>
--- a/SecureCoating-Vision_Final_Defense_6min.pptx
+++ b/SecureCoating-Vision_Final_Defense_6min.pptx
@@ -9347,7 +9347,7 @@
         <p:spPr>
           <a:xfrm>
             <a:off x="411480" y="457200"/>
-            <a:ext cx="11338560" cy="502920"/>
+            <a:ext cx="11338560" cy="411480"/>
           </a:xfrm>
           <a:prstGeom prst="rect">
             <a:avLst/>
@@ -9372,7 +9372,7 @@
                 </a:solidFill>
                 <a:latin typeface="Calibri"/>
               </a:rPr>
-              <a:t>Real detection. Safe demo disposition. Clear next gate.</a:t>
+              <a:t>Let the loops run. Then say the close.</a:t>
             </a:r>
           </a:p>
         </p:txBody>
@@ -9385,8 +9385,8 @@
         </p:nvSpPr>
         <p:spPr>
           <a:xfrm>
-            <a:off x="411480" y="1051560"/>
-            <a:ext cx="5532120" cy="1115568"/>
+            <a:off x="411480" y="960120"/>
+            <a:ext cx="5623560" cy="3703320"/>
           </a:xfrm>
           <a:prstGeom prst="rect">
             <a:avLst/>
@@ -9430,8 +9430,8 @@
         </p:nvSpPr>
         <p:spPr>
           <a:xfrm>
-            <a:off x="594360" y="1161288"/>
-            <a:ext cx="5120640" cy="274320"/>
+            <a:off x="548640" y="1024128"/>
+            <a:ext cx="5349240" cy="256032"/>
           </a:xfrm>
           <a:prstGeom prst="rect">
             <a:avLst/>
@@ -9450,56 +9450,41 @@
               </a:spcAft>
             </a:pPr>
             <a:r>
-              <a:rPr sz="1400" b="1">
-                <a:solidFill>
-                  <a:srgbClr val="00E676"/>
-                </a:solidFill>
-                <a:latin typeface="Calibri"/>
-              </a:rPr>
-              <a:t>CASE 1  ·  REAL OPTICAL</a:t>
-            </a:r>
-          </a:p>
-        </p:txBody>
-      </p:sp>
-      <p:sp>
-        <p:nvSpPr>
-          <p:cNvPr id="9" name="TextBox 8"/>
-          <p:cNvSpPr txBox="1"/>
-          <p:nvPr/>
-        </p:nvSpPr>
-        <p:spPr>
-          <a:xfrm>
-            <a:off x="594360" y="1508760"/>
-            <a:ext cx="5120640" cy="502920"/>
-          </a:xfrm>
-          <a:prstGeom prst="rect">
-            <a:avLst/>
-          </a:prstGeom>
-          <a:noFill/>
-        </p:spPr>
-        <p:txBody>
-          <a:bodyPr wrap="square">
-            <a:spAutoFit/>
-          </a:bodyPr>
-          <a:lstStyle/>
-          <a:p>
-            <a:pPr algn="l">
-              <a:spcAft>
-                <a:spcPts val="600"/>
-              </a:spcAft>
-            </a:pPr>
-            <a:r>
-              <a:rPr sz="1600" b="0">
-                <a:solidFill>
-                  <a:srgbClr val="FFFFFF"/>
-                </a:solidFill>
-                <a:latin typeface="Calibri"/>
-              </a:rPr>
-              <a:t>CoatingVision image · DOI + SHA-256</a:t>
-            </a:r>
-          </a:p>
-        </p:txBody>
-      </p:sp>
+              <a:rPr sz="1200" b="1">
+                <a:solidFill>
+                  <a:srgbClr val="FFD600"/>
+                </a:solidFill>
+                <a:latin typeface="Calibri"/>
+              </a:rPr>
+              <a:t>RGB LANE  ·  image_1548  ·  HOLD</a:t>
+            </a:r>
+          </a:p>
+        </p:txBody>
+      </p:sp>
+      <p:pic>
+        <p:nvPicPr>
+          <p:cNvPr id="9" name="Picture 8" descr="rgb_hold_replay.gif"/>
+          <p:cNvPicPr>
+            <a:picLocks noChangeAspect="1"/>
+          </p:cNvPicPr>
+          <p:nvPr/>
+        </p:nvPicPr>
+        <p:blipFill>
+          <a:blip r:embed="rId2"/>
+          <a:stretch>
+            <a:fillRect/>
+          </a:stretch>
+        </p:blipFill>
+        <p:spPr>
+          <a:xfrm>
+            <a:off x="548640" y="1325880"/>
+            <a:ext cx="5349240" cy="3365564"/>
+          </a:xfrm>
+          <a:prstGeom prst="rect">
+            <a:avLst/>
+          </a:prstGeom>
+        </p:spPr>
+      </p:pic>
       <p:sp>
         <p:nvSpPr>
           <p:cNvPr id="10" name="Rectangle 9"/>
@@ -9508,8 +9493,8 @@
         </p:nvSpPr>
         <p:spPr>
           <a:xfrm>
-            <a:off x="6172200" y="1051560"/>
-            <a:ext cx="5532120" cy="1115568"/>
+            <a:off x="6172200" y="960120"/>
+            <a:ext cx="5623560" cy="3703320"/>
           </a:xfrm>
           <a:prstGeom prst="rect">
             <a:avLst/>
@@ -9553,8 +9538,8 @@
         </p:nvSpPr>
         <p:spPr>
           <a:xfrm>
-            <a:off x="6355080" y="1161288"/>
-            <a:ext cx="5120640" cy="274320"/>
+            <a:off x="6309360" y="1024128"/>
+            <a:ext cx="5349240" cy="256032"/>
           </a:xfrm>
           <a:prstGeom prst="rect">
             <a:avLst/>
@@ -9573,436 +9558,35 @@
               </a:spcAft>
             </a:pPr>
             <a:r>
-              <a:rPr sz="1400" b="1">
-                <a:solidFill>
-                  <a:srgbClr val="FF1744"/>
-                </a:solidFill>
-                <a:latin typeface="Calibri"/>
-              </a:rPr>
-              <a:t>CASE 2  ·  surface_crack</a:t>
-            </a:r>
-          </a:p>
-        </p:txBody>
-      </p:sp>
-      <p:sp>
-        <p:nvSpPr>
-          <p:cNvPr id="12" name="TextBox 11"/>
-          <p:cNvSpPr txBox="1"/>
-          <p:nvPr/>
-        </p:nvSpPr>
-        <p:spPr>
-          <a:xfrm>
-            <a:off x="6355080" y="1508760"/>
-            <a:ext cx="5120640" cy="502920"/>
-          </a:xfrm>
-          <a:prstGeom prst="rect">
-            <a:avLst/>
-          </a:prstGeom>
-          <a:noFill/>
-        </p:spPr>
-        <p:txBody>
-          <a:bodyPr wrap="square">
-            <a:spAutoFit/>
-          </a:bodyPr>
-          <a:lstStyle/>
-          <a:p>
-            <a:pPr algn="l">
-              <a:spcAft>
-                <a:spcPts val="600"/>
-              </a:spcAft>
-            </a:pPr>
-            <a:r>
-              <a:rPr sz="1600" b="0">
-                <a:solidFill>
-                  <a:srgbClr val="FFFFFF"/>
-                </a:solidFill>
-                <a:latin typeface="Calibri"/>
-              </a:rPr>
-              <a:t>confidence 0.53 · artifact f72a8f2b…</a:t>
-            </a:r>
-          </a:p>
-        </p:txBody>
-      </p:sp>
-      <p:sp>
-        <p:nvSpPr>
-          <p:cNvPr id="13" name="Rectangle 12"/>
-          <p:cNvSpPr/>
-          <p:nvPr/>
-        </p:nvSpPr>
-        <p:spPr>
-          <a:xfrm>
-            <a:off x="411480" y="2286000"/>
-            <a:ext cx="5532120" cy="1115568"/>
-          </a:xfrm>
-          <a:prstGeom prst="rect">
-            <a:avLst/>
-          </a:prstGeom>
-          <a:solidFill>
-            <a:srgbClr val="151B28"/>
-          </a:solidFill>
-          <a:ln w="6350">
-            <a:solidFill>
-              <a:srgbClr val="222C3E"/>
-            </a:solidFill>
-          </a:ln>
-        </p:spPr>
-        <p:style>
-          <a:lnRef idx="1">
-            <a:schemeClr val="accent1"/>
-          </a:lnRef>
-          <a:fillRef idx="3">
-            <a:schemeClr val="accent1"/>
-          </a:fillRef>
-          <a:effectRef idx="2">
-            <a:schemeClr val="accent1"/>
-          </a:effectRef>
-          <a:fontRef idx="minor">
-            <a:schemeClr val="lt1"/>
-          </a:fontRef>
-        </p:style>
-        <p:txBody>
-          <a:bodyPr rtlCol="0" anchor="ctr"/>
-          <a:lstStyle/>
-          <a:p>
-            <a:pPr algn="ctr"/>
-          </a:p>
-        </p:txBody>
-      </p:sp>
-      <p:sp>
-        <p:nvSpPr>
-          <p:cNvPr id="14" name="TextBox 13"/>
-          <p:cNvSpPr txBox="1"/>
-          <p:nvPr/>
-        </p:nvSpPr>
-        <p:spPr>
-          <a:xfrm>
-            <a:off x="594360" y="2395728"/>
-            <a:ext cx="5120640" cy="274320"/>
-          </a:xfrm>
-          <a:prstGeom prst="rect">
-            <a:avLst/>
-          </a:prstGeom>
-          <a:noFill/>
-        </p:spPr>
-        <p:txBody>
-          <a:bodyPr wrap="square">
-            <a:spAutoFit/>
-          </a:bodyPr>
-          <a:lstStyle/>
-          <a:p>
-            <a:pPr algn="l">
-              <a:spcAft>
-                <a:spcPts val="600"/>
-              </a:spcAft>
-            </a:pPr>
-            <a:r>
-              <a:rPr sz="1400" b="1">
-                <a:solidFill>
-                  <a:srgbClr val="FF1744"/>
-                </a:solidFill>
-                <a:latin typeface="Calibri"/>
-              </a:rPr>
-              <a:t>CASE 3  ·  PYTORCH + ONNX</a:t>
-            </a:r>
-          </a:p>
-        </p:txBody>
-      </p:sp>
-      <p:sp>
-        <p:nvSpPr>
-          <p:cNvPr id="15" name="TextBox 14"/>
-          <p:cNvSpPr txBox="1"/>
-          <p:nvPr/>
-        </p:nvSpPr>
-        <p:spPr>
-          <a:xfrm>
-            <a:off x="594360" y="2743200"/>
-            <a:ext cx="5120640" cy="502920"/>
-          </a:xfrm>
-          <a:prstGeom prst="rect">
-            <a:avLst/>
-          </a:prstGeom>
-          <a:noFill/>
-        </p:spPr>
-        <p:txBody>
-          <a:bodyPr wrap="square">
-            <a:spAutoFit/>
-          </a:bodyPr>
-          <a:lstStyle/>
-          <a:p>
-            <a:pPr algn="l">
-              <a:spcAft>
-                <a:spcPts val="600"/>
-              </a:spcAft>
-            </a:pPr>
-            <a:r>
-              <a:rPr sz="1600" b="0">
-                <a:solidFill>
-                  <a:srgbClr val="FFFFFF"/>
-                </a:solidFill>
-                <a:latin typeface="Calibri"/>
-              </a:rPr>
-              <a:t>same 2-class map · hash-pinned artifacts</a:t>
-            </a:r>
-          </a:p>
-        </p:txBody>
-      </p:sp>
-      <p:sp>
-        <p:nvSpPr>
-          <p:cNvPr id="16" name="Rectangle 15"/>
-          <p:cNvSpPr/>
-          <p:nvPr/>
-        </p:nvSpPr>
-        <p:spPr>
-          <a:xfrm>
-            <a:off x="6172200" y="2286000"/>
-            <a:ext cx="5532120" cy="1115568"/>
-          </a:xfrm>
-          <a:prstGeom prst="rect">
-            <a:avLst/>
-          </a:prstGeom>
-          <a:solidFill>
-            <a:srgbClr val="151B28"/>
-          </a:solidFill>
-          <a:ln w="6350">
-            <a:solidFill>
-              <a:srgbClr val="222C3E"/>
-            </a:solidFill>
-          </a:ln>
-        </p:spPr>
-        <p:style>
-          <a:lnRef idx="1">
-            <a:schemeClr val="accent1"/>
-          </a:lnRef>
-          <a:fillRef idx="3">
-            <a:schemeClr val="accent1"/>
-          </a:fillRef>
-          <a:effectRef idx="2">
-            <a:schemeClr val="accent1"/>
-          </a:effectRef>
-          <a:fontRef idx="minor">
-            <a:schemeClr val="lt1"/>
-          </a:fontRef>
-        </p:style>
-        <p:txBody>
-          <a:bodyPr rtlCol="0" anchor="ctr"/>
-          <a:lstStyle/>
-          <a:p>
-            <a:pPr algn="ctr"/>
-          </a:p>
-        </p:txBody>
-      </p:sp>
-      <p:sp>
-        <p:nvSpPr>
-          <p:cNvPr id="17" name="TextBox 16"/>
-          <p:cNvSpPr txBox="1"/>
-          <p:nvPr/>
-        </p:nvSpPr>
-        <p:spPr>
-          <a:xfrm>
-            <a:off x="6355080" y="2395728"/>
-            <a:ext cx="5120640" cy="274320"/>
-          </a:xfrm>
-          <a:prstGeom prst="rect">
-            <a:avLst/>
-          </a:prstGeom>
-          <a:noFill/>
-        </p:spPr>
-        <p:txBody>
-          <a:bodyPr wrap="square">
-            <a:spAutoFit/>
-          </a:bodyPr>
-          <a:lstStyle/>
-          <a:p>
-            <a:pPr algn="l">
-              <a:spcAft>
-                <a:spcPts val="600"/>
-              </a:spcAft>
-            </a:pPr>
-            <a:r>
-              <a:rPr sz="1400" b="1">
-                <a:solidFill>
-                  <a:srgbClr val="FFD600"/>
-                </a:solidFill>
-                <a:latin typeface="Calibri"/>
-              </a:rPr>
-              <a:t>CASE 4  ·  HOLD</a:t>
-            </a:r>
-          </a:p>
-        </p:txBody>
-      </p:sp>
-      <p:sp>
-        <p:nvSpPr>
-          <p:cNvPr id="18" name="TextBox 17"/>
-          <p:cNvSpPr txBox="1"/>
-          <p:nvPr/>
-        </p:nvSpPr>
-        <p:spPr>
-          <a:xfrm>
-            <a:off x="6355080" y="2743200"/>
-            <a:ext cx="5120640" cy="502920"/>
-          </a:xfrm>
-          <a:prstGeom prst="rect">
-            <a:avLst/>
-          </a:prstGeom>
-          <a:noFill/>
-        </p:spPr>
-        <p:txBody>
-          <a:bodyPr wrap="square">
-            <a:spAutoFit/>
-          </a:bodyPr>
-          <a:lstStyle/>
-          <a:p>
-            <a:pPr algn="l">
-              <a:spcAft>
-                <a:spcPts val="600"/>
-              </a:spcAft>
-            </a:pPr>
-            <a:r>
-              <a:rPr sz="1600" b="0">
-                <a:solidFill>
-                  <a:srgbClr val="FFFFFF"/>
-                </a:solidFill>
-                <a:latin typeface="Calibri"/>
-              </a:rPr>
-              <a:t>mock PLC + unverified calibration block release</a:t>
-            </a:r>
-          </a:p>
-        </p:txBody>
-      </p:sp>
-      <p:sp>
-        <p:nvSpPr>
-          <p:cNvPr id="19" name="TextBox 18"/>
-          <p:cNvSpPr txBox="1"/>
-          <p:nvPr/>
-        </p:nvSpPr>
-        <p:spPr>
-          <a:xfrm>
-            <a:off x="411480" y="3657600"/>
-            <a:ext cx="6949440" cy="2377440"/>
-          </a:xfrm>
-          <a:prstGeom prst="rect">
-            <a:avLst/>
-          </a:prstGeom>
-          <a:noFill/>
-        </p:spPr>
-        <p:txBody>
-          <a:bodyPr wrap="square">
-            <a:spAutoFit/>
-          </a:bodyPr>
-          <a:lstStyle/>
-          <a:p>
-            <a:pPr algn="l">
-              <a:spcAft>
-                <a:spcPts val="600"/>
-              </a:spcAft>
-            </a:pPr>
-            <a:r>
               <a:rPr sz="1200" b="1">
                 <a:solidFill>
                   <a:srgbClr val="00E5FF"/>
                 </a:solidFill>
                 <a:latin typeface="Calibri"/>
               </a:rPr>
-              <a:t>CLOSE</a:t>
-            </a:r>
-          </a:p>
-          <a:p>
-            <a:pPr algn="l">
-              <a:spcAft>
-                <a:spcPts val="1000"/>
-              </a:spcAft>
-            </a:pPr>
-            <a:r>
-              <a:rPr sz="1800" b="1">
-                <a:solidFill>
-                  <a:srgbClr val="FFFFFF"/>
-                </a:solidFill>
-                <a:latin typeface="Calibri"/>
-              </a:rPr>
-              <a:t>The model finds defects. The evidence gate controls when the line may act.</a:t>
-            </a:r>
-          </a:p>
-          <a:p>
-            <a:pPr algn="l">
-              <a:spcAft>
-                <a:spcPts val="600"/>
-              </a:spcAft>
-            </a:pPr>
-            <a:r>
-              <a:rPr sz="1400" b="0">
-                <a:solidFill>
-                  <a:srgbClr val="8C9BAE"/>
-                </a:solidFill>
-                <a:latin typeface="Calibri"/>
-              </a:rPr>
-              <a:t>Next gate: supervised pilot with HIL, factory calibration, and roll-disjoint data.</a:t>
-            </a:r>
-          </a:p>
-        </p:txBody>
-      </p:sp>
-      <p:sp>
-        <p:nvSpPr>
-          <p:cNvPr id="20" name="Rectangle 19"/>
-          <p:cNvSpPr/>
-          <p:nvPr/>
-        </p:nvSpPr>
-        <p:spPr>
-          <a:xfrm>
-            <a:off x="7498079" y="3611880"/>
-            <a:ext cx="4251960" cy="2468880"/>
-          </a:xfrm>
-          <a:prstGeom prst="rect">
-            <a:avLst/>
-          </a:prstGeom>
-          <a:solidFill>
-            <a:srgbClr val="151B28"/>
-          </a:solidFill>
-          <a:ln w="6350">
-            <a:solidFill>
-              <a:srgbClr val="222C3E"/>
-            </a:solidFill>
-          </a:ln>
-        </p:spPr>
-        <p:style>
-          <a:lnRef idx="1">
-            <a:schemeClr val="accent1"/>
-          </a:lnRef>
-          <a:fillRef idx="3">
-            <a:schemeClr val="accent1"/>
-          </a:fillRef>
-          <a:effectRef idx="2">
-            <a:schemeClr val="accent1"/>
-          </a:effectRef>
-          <a:fontRef idx="minor">
-            <a:schemeClr val="lt1"/>
-          </a:fontRef>
-        </p:style>
-        <p:txBody>
-          <a:bodyPr rtlCol="0" anchor="ctr"/>
-          <a:lstStyle/>
-          <a:p>
-            <a:pPr algn="ctr"/>
+              <a:t>LIBAD GATE  ·  fixture PASS / REJECT / REJECT / HOLD</a:t>
+            </a:r>
           </a:p>
         </p:txBody>
       </p:sp>
       <p:pic>
         <p:nvPicPr>
-          <p:cNvPr id="21" name="Picture 20" descr="coatingvision_model_output.png"/>
+          <p:cNvPr id="12" name="Picture 11" descr="libad_gate.gif"/>
           <p:cNvPicPr>
             <a:picLocks noChangeAspect="1"/>
           </p:cNvPicPr>
           <p:nvPr/>
         </p:nvPicPr>
         <p:blipFill>
-          <a:blip r:embed="rId2"/>
+          <a:blip r:embed="rId3"/>
           <a:stretch>
             <a:fillRect/>
           </a:stretch>
         </p:blipFill>
         <p:spPr>
           <a:xfrm>
-            <a:off x="7635240" y="3749039"/>
-            <a:ext cx="3977639" cy="2983229"/>
+            <a:off x="6309360" y="1325880"/>
+            <a:ext cx="5349240" cy="4041648"/>
           </a:xfrm>
           <a:prstGeom prst="rect">
             <a:avLst/>
@@ -10011,14 +9595,14 @@
       </p:pic>
       <p:sp>
         <p:nvSpPr>
-          <p:cNvPr id="22" name="TextBox 21"/>
+          <p:cNvPr id="13" name="TextBox 12"/>
           <p:cNvSpPr txBox="1"/>
           <p:nvPr/>
         </p:nvSpPr>
         <p:spPr>
           <a:xfrm>
-            <a:off x="411480" y="6510528"/>
-            <a:ext cx="7772400" cy="256032"/>
+            <a:off x="411480" y="4800600"/>
+            <a:ext cx="11338560" cy="1508760"/>
           </a:xfrm>
           <a:prstGeom prst="rect">
             <a:avLst/>
@@ -10037,6 +9621,77 @@
               </a:spcAft>
             </a:pPr>
             <a:r>
+              <a:rPr sz="1200" b="1">
+                <a:solidFill>
+                  <a:srgbClr val="00E5FF"/>
+                </a:solidFill>
+                <a:latin typeface="Calibri"/>
+              </a:rPr>
+              <a:t>CLOSE</a:t>
+            </a:r>
+          </a:p>
+          <a:p>
+            <a:pPr algn="l">
+              <a:spcAft>
+                <a:spcPts val="800"/>
+              </a:spcAft>
+            </a:pPr>
+            <a:r>
+              <a:rPr sz="2000" b="1">
+                <a:solidFill>
+                  <a:srgbClr val="FFFFFF"/>
+                </a:solidFill>
+                <a:latin typeface="Calibri"/>
+              </a:rPr>
+              <a:t>The model finds defects. The evidence gate controls when the line may act.</a:t>
+            </a:r>
+          </a:p>
+          <a:p>
+            <a:pPr algn="l">
+              <a:spcAft>
+                <a:spcPts val="600"/>
+              </a:spcAft>
+            </a:pPr>
+            <a:r>
+              <a:rPr sz="1400" b="0">
+                <a:solidFill>
+                  <a:srgbClr val="8C9BAE"/>
+                </a:solidFill>
+                <a:latin typeface="Calibri"/>
+              </a:rPr>
+              <a:t>GIFs loop checked-in artifacts. RGB HOLD is real optical + mock PLC. LIBAD cases are protocol fixtures, not DINOv3. Next gate: HIL, factory calibration, roll-disjoint data.</a:t>
+            </a:r>
+          </a:p>
+        </p:txBody>
+      </p:sp>
+      <p:sp>
+        <p:nvSpPr>
+          <p:cNvPr id="14" name="TextBox 13"/>
+          <p:cNvSpPr txBox="1"/>
+          <p:nvPr/>
+        </p:nvSpPr>
+        <p:spPr>
+          <a:xfrm>
+            <a:off x="411480" y="6510528"/>
+            <a:ext cx="7772400" cy="256032"/>
+          </a:xfrm>
+          <a:prstGeom prst="rect">
+            <a:avLst/>
+          </a:prstGeom>
+          <a:noFill/>
+        </p:spPr>
+        <p:txBody>
+          <a:bodyPr wrap="square">
+            <a:spAutoFit/>
+          </a:bodyPr>
+          <a:lstStyle/>
+          <a:p>
+            <a:pPr algn="l">
+              <a:spcAft>
+                <a:spcPts val="600"/>
+              </a:spcAft>
+            </a:pPr>
+            <a:r>
               <a:rPr sz="1100" b="0">
                 <a:solidFill>
                   <a:srgbClr val="8C9BAE"/>
@@ -10050,7 +9705,7 @@
       </p:sp>
       <p:sp>
         <p:nvSpPr>
-          <p:cNvPr id="23" name="TextBox 22"/>
+          <p:cNvPr id="15" name="TextBox 14"/>
           <p:cNvSpPr txBox="1"/>
           <p:nvPr/>
         </p:nvSpPr>

</xml_diff>

<commit_message>
Fix CI evidence gates and sync DINOv2 interim metrics into defense surfaces.
Keep comparable_to_paper false; expose authors interim beside numpy 10-seed without overselling paper DINOv3.

Co-authored-by: Cursor <cursoragent@cursor.com>
</commit_message>
<xml_diff>
--- a/SecureCoating-Vision_Final_Defense_6min.pptx
+++ b/SecureCoating-Vision_Final_Defense_6min.pptx
@@ -5326,7 +5326,7 @@
                 </a:solidFill>
                 <a:latin typeface="Calibri"/>
               </a:rPr>
-              <a:t>Official 10-seed ran on a hash-verified mount with the local CPU numpy descriptor (AUROC ~0.70, FPR95 ~0.84). Not DINOv3. Demo cases stay protocol fixtures.</a:t>
+              <a:t>Official mount hashed. Numpy 10-seed ~AUROC 0.70 / FPR95 0.84. Authors' runner interim DINOv2 (1 seed) ~AUROC 0.856 / FPR95 0.716 — still not paper DINOv3. Demo cases stay protocol fixtures.</a:t>
             </a:r>
           </a:p>
           <a:p>
@@ -10532,7 +10532,7 @@
                 </a:solidFill>
                 <a:latin typeface="Calibri"/>
               </a:rPr>
-              <a:t>GIFs loop checked-in artifacts. RGB HOLD is real optical + mock PLC. LIBAD cases are protocol fixtures, not DINOv3. Next gate: HIL, factory calibration, roll-disjoint data.</a:t>
+              <a:t>GIFs loop checked-in artifacts. RGB HOLD is real optical + mock PLC. LIBAD fixtures stay protocol fixtures. Authors' interim is DINOv2 1-seed, not DINOv3. Next gate: HIL, factory calibration, roll-disjoint data.</a:t>
             </a:r>
           </a:p>
         </p:txBody>

</xml_diff>

<commit_message>
Fix submission ZIP packaging so the packed artifact actually imports.
Whitelist hardware_profile and GPU/CI docs, verify unzip→import→collect after build, and tighten defense slides/pitch claim hygiene around HOLD vs factory safety.

Co-authored-by: Cursor <cursoragent@cursor.com>
</commit_message>
<xml_diff>
--- a/SecureCoating-Vision_Final_Defense_6min.pptx
+++ b/SecureCoating-Vision_Final_Defense_6min.pptx
@@ -6227,7 +6227,7 @@
                 </a:solidFill>
                 <a:latin typeface="Calibri"/>
               </a:rPr>
-              <a:t>INDUSTRIAL MEANING</a:t>
+              <a:t>SOFTWARE SAFETY SEMANTICS</a:t>
             </a:r>
           </a:p>
           <a:p>
@@ -6237,13 +6237,13 @@
               </a:spcAft>
             </a:pPr>
             <a:r>
-              <a:rPr sz="2000" b="1">
+              <a:rPr sz="1800" b="1">
                 <a:solidFill>
                   <a:srgbClr val="1A1F2B"/>
                 </a:solidFill>
                 <a:latin typeface="Calibri"/>
               </a:rPr>
-              <a:t>Uncertainty becomes a controlled operational state, not a hidden false-positive rate.</a:t>
+              <a:t>Uncertainty becomes a controlled software state — not a claim of factory-qualified process safety.</a:t>
             </a:r>
           </a:p>
           <a:p>
@@ -6253,13 +6253,13 @@
               </a:spcAft>
             </a:pPr>
             <a:r>
-              <a:rPr sz="1500" b="0">
+              <a:rPr sz="1400" b="0">
                 <a:solidFill>
                   <a:srgbClr val="5C6775"/>
                 </a:solidFill>
                 <a:latin typeface="Calibri"/>
               </a:rPr>
-              <a:t>Software E-stop latches local interlock and requests PLC channels. It is not a safety-rated hardwired stop.</a:t>
+              <a:t>Local LIBAD adapter gate metrics (escape ~51% / HOLD ~5%) evaluate semantics, not a plant operating point. Software E-stop latches local interlock and requests PLC channels; it is not a safety-rated hardwired stop.</a:t>
             </a:r>
           </a:p>
         </p:txBody>
@@ -7510,13 +7510,13 @@
               </a:spcAft>
             </a:pPr>
             <a:r>
-              <a:rPr sz="2800" b="1">
+              <a:rPr sz="2400" b="1">
                 <a:solidFill>
                   <a:srgbClr val="1A1F2B"/>
                 </a:solidFill>
                 <a:latin typeface="Calibri"/>
               </a:rPr>
-              <a:t>Trace first. Command second. ACK or HOLD.</a:t>
+              <a:t>Intent → command → ACK. HOLD is requested, then confirmed.</a:t>
             </a:r>
           </a:p>
         </p:txBody>
@@ -8297,7 +8297,7 @@
                 </a:solidFill>
                 <a:latin typeface="Calibri"/>
               </a:rPr>
-              <a:t>Finalize</a:t>
+              <a:t>Confirm</a:t>
             </a:r>
           </a:p>
         </p:txBody>
@@ -8336,7 +8336,7 @@
                 </a:solidFill>
                 <a:latin typeface="Calibri"/>
               </a:rPr>
-              <a:t>PASS/REJECT, or HOLD if ACK fails</a:t>
+              <a:t>PASS/REJECT only after ACK; HOLD_REQUESTED ≠ HOLD_CONFIRMED</a:t>
             </a:r>
           </a:p>
         </p:txBody>
@@ -10510,13 +10510,13 @@
               </a:spcAft>
             </a:pPr>
             <a:r>
-              <a:rPr sz="2000" b="1">
+              <a:rPr sz="1800" b="1">
                 <a:solidFill>
                   <a:srgbClr val="1A1F2B"/>
                 </a:solidFill>
                 <a:latin typeface="Calibri"/>
               </a:rPr>
-              <a:t>The model finds defects. The evidence gate controls when the line may act.</a:t>
+              <a:t>The model finds defects. The evidence gate controls when software may authorize a disposition.</a:t>
             </a:r>
           </a:p>
           <a:p>
@@ -10526,13 +10526,13 @@
               </a:spcAft>
             </a:pPr>
             <a:r>
-              <a:rPr sz="1400" b="0">
+              <a:rPr sz="1300" b="0">
                 <a:solidFill>
                   <a:srgbClr val="5C6775"/>
                 </a:solidFill>
                 <a:latin typeface="Calibri"/>
               </a:rPr>
-              <a:t>GIFs loop checked-in artifacts. RGB HOLD is real optical + mock PLC. LIBAD fixtures stay protocol fixtures. Authors' interim is DINOv2 1-seed, not DINOv3. Next gate: HIL, factory calibration, roll-disjoint data.</a:t>
+              <a:t>Registered title states the target Zero-Trust Edge-Cloud architecture; this artifact validates inspection, evidence, and fail-closed contracts — not completed mTLS/RBAC/OT. GIFs loop checked-in artifacts. Authors' interim is DINOv2 1-seed, not DINOv3.</a:t>
             </a:r>
           </a:p>
         </p:txBody>

</xml_diff>

<commit_message>
Fix regenerator/slide fingerprint drift and pack raw pytest evidence paths.
Co-authored-by: Cursor <cursoragent@cursor.com>
</commit_message>
<xml_diff>
--- a/SecureCoating-Vision_Final_Defense_6min.pptx
+++ b/SecureCoating-Vision_Final_Defense_6min.pptx
@@ -4608,7 +4608,7 @@
                 </a:solidFill>
                 <a:latin typeface="Calibri"/>
               </a:rPr>
-              <a:t>88 held-out images · mAP50 0.633</a:t>
+              <a:t>88 held-out images · mAP50 0.634</a:t>
             </a:r>
           </a:p>
           <a:p>
@@ -9582,7 +9582,7 @@
                 </a:solidFill>
                 <a:latin typeface="Calibri"/>
               </a:rPr>
-              <a:t>63.3%</a:t>
+              <a:t>63.4%</a:t>
             </a:r>
           </a:p>
         </p:txBody>
@@ -9969,7 +9969,7 @@
                 </a:solidFill>
                 <a:latin typeface="Calibri"/>
               </a:rPr>
-              <a:t>88 test images  ·  seed 71  ·  weights f72a8f2b…  ·  dataset 3c3f2773…</a:t>
+              <a:t>88 test images  ·  seed 71  ·  weights f72a8f2b…  ·  dataset d1db7823…</a:t>
             </a:r>
           </a:p>
           <a:p>

</xml_diff>

<commit_message>
Canonicalize manifest CRLF and clear final-defense claim/layout traps.
Keep byte-stable CoatingVision hashes on Linux, stop Slide 8 media from covering the close line, and separate roll-disjoint qualification from image-disjoint RGB evidence.

Co-authored-by: Cursor <cursoragent@cursor.com>
</commit_message>
<xml_diff>
--- a/SecureCoating-Vision_Final_Defense_6min.pptx
+++ b/SecureCoating-Vision_Final_Defense_6min.pptx
@@ -6259,7 +6259,7 @@
                 </a:solidFill>
                 <a:latin typeface="Calibri"/>
               </a:rPr>
-              <a:t>Local LIBAD adapter gate metrics (escape ~51% / HOLD ~5%) evaluate semantics, not a plant operating point. Software E-stop latches local interlock and requests PLC channels; it is not a safety-rated hardwired stop.</a:t>
+              <a:t>Readiness failure → HOLD. PASS/REJECT require confirmed control evidence. No readiness gate, no automatic release. Software E-stop latches local interlock and requests PLC channels; it is not a safety-rated hardwired stop.</a:t>
             </a:r>
           </a:p>
         </p:txBody>
@@ -10350,8 +10350,8 @@
         </p:blipFill>
         <p:spPr>
           <a:xfrm>
-            <a:off x="548640" y="1325880"/>
-            <a:ext cx="5349240" cy="3365564"/>
+            <a:off x="643561" y="1325880"/>
+            <a:ext cx="5159396" cy="3246120"/>
           </a:xfrm>
           <a:prstGeom prst="rect">
             <a:avLst/>
@@ -10458,8 +10458,8 @@
         </p:blipFill>
         <p:spPr>
           <a:xfrm>
-            <a:off x="6309360" y="1325880"/>
-            <a:ext cx="5349240" cy="4041648"/>
+            <a:off x="6835812" y="1325880"/>
+            <a:ext cx="4296335" cy="3246120"/>
           </a:xfrm>
           <a:prstGeom prst="rect">
             <a:avLst/>

</xml_diff>

<commit_message>
Clarify Team 71 branding and ship an intentional competition ZIP.
Drop organizer-lab product logo, keep advisor subordinate on Slide 1/README/DOCX, add industrialization_path, and exclude failed DINOv3/stale gallery dumps from the release archive.

Co-authored-by: Cursor <cursoragent@cursor.com>
</commit_message>
<xml_diff>
--- a/SecureCoating-Vision_Final_Defense_6min.pptx
+++ b/SecureCoating-Vision_Final_Defense_6min.pptx
@@ -3181,40 +3181,16 @@
           </a:p>
         </p:txBody>
       </p:sp>
-      <p:pic>
-        <p:nvPicPr>
-          <p:cNvPr id="4" name="Picture 3" descr="logo.png"/>
-          <p:cNvPicPr>
-            <a:picLocks noChangeAspect="1"/>
-          </p:cNvPicPr>
-          <p:nvPr/>
-        </p:nvPicPr>
-        <p:blipFill>
-          <a:blip r:embed="rId2"/>
-          <a:stretch>
-            <a:fillRect/>
-          </a:stretch>
-        </p:blipFill>
-        <p:spPr>
-          <a:xfrm>
-            <a:off x="411480" y="201168"/>
-            <a:ext cx="4297680" cy="935843"/>
-          </a:xfrm>
-          <a:prstGeom prst="rect">
-            <a:avLst/>
-          </a:prstGeom>
-        </p:spPr>
-      </p:pic>
-      <p:sp>
-        <p:nvSpPr>
-          <p:cNvPr id="5" name="TextBox 4"/>
+      <p:sp>
+        <p:nvSpPr>
+          <p:cNvPr id="4" name="TextBox 3"/>
           <p:cNvSpPr txBox="1"/>
           <p:nvPr/>
         </p:nvSpPr>
         <p:spPr>
           <a:xfrm>
-            <a:off x="6766560" y="201168"/>
-            <a:ext cx="4983480" cy="960120"/>
+            <a:off x="411480" y="320040"/>
+            <a:ext cx="11338560" cy="320040"/>
           </a:xfrm>
           <a:prstGeom prst="rect">
             <a:avLst/>
@@ -3227,65 +3203,33 @@
           </a:bodyPr>
           <a:lstStyle/>
           <a:p>
-            <a:pPr algn="r">
-              <a:spcAft>
-                <a:spcPts val="400"/>
-              </a:spcAft>
-            </a:pPr>
-            <a:r>
-              <a:rPr sz="1100" b="1">
+            <a:pPr algn="l">
+              <a:spcAft>
+                <a:spcPts val="600"/>
+              </a:spcAft>
+            </a:pPr>
+            <a:r>
+              <a:rPr sz="1400" b="1">
                 <a:solidFill>
                   <a:srgbClr val="1F5EB8"/>
                 </a:solidFill>
                 <a:latin typeface="Calibri"/>
               </a:rPr>
-              <a:t>GLOBAL AI + MATERIALS INNOVATION COMPETITION 2026</a:t>
-            </a:r>
-          </a:p>
-          <a:p>
-            <a:pPr algn="r">
-              <a:spcAft>
-                <a:spcPts val="200"/>
-              </a:spcAft>
-            </a:pPr>
-            <a:r>
-              <a:rPr sz="1200" b="1">
-                <a:solidFill>
-                  <a:srgbClr val="1A1F2B"/>
-                </a:solidFill>
-                <a:latin typeface="Calibri"/>
-              </a:rPr>
-              <a:t>TRACK 4  ·  AI + MATERIALS TESTING AND CHARACTERIZATION</a:t>
-            </a:r>
-          </a:p>
-          <a:p>
-            <a:pPr algn="r">
-              <a:spcAft>
-                <a:spcPts val="600"/>
-              </a:spcAft>
-            </a:pPr>
-            <a:r>
-              <a:rPr sz="1200" b="0">
-                <a:solidFill>
-                  <a:srgbClr val="5C6775"/>
-                </a:solidFill>
-                <a:latin typeface="Calibri"/>
-              </a:rPr>
-              <a:t>人工智能 + 材料检测与表征</a:t>
-            </a:r>
-          </a:p>
-        </p:txBody>
-      </p:sp>
-      <p:sp>
-        <p:nvSpPr>
-          <p:cNvPr id="6" name="TextBox 5"/>
+              <a:t>Global AI + Materials Innovation Application Competition 2026</a:t>
+            </a:r>
+          </a:p>
+        </p:txBody>
+      </p:sp>
+      <p:sp>
+        <p:nvSpPr>
+          <p:cNvPr id="5" name="TextBox 4"/>
           <p:cNvSpPr txBox="1"/>
           <p:nvPr/>
         </p:nvSpPr>
         <p:spPr>
           <a:xfrm>
-            <a:off x="411480" y="1325880"/>
-            <a:ext cx="11338560" cy="365760"/>
+            <a:off x="411480" y="960120"/>
+            <a:ext cx="11338560" cy="411480"/>
           </a:xfrm>
           <a:prstGeom prst="rect">
             <a:avLst/>
@@ -3304,26 +3248,26 @@
               </a:spcAft>
             </a:pPr>
             <a:r>
-              <a:rPr sz="2800" b="1">
+              <a:rPr sz="3200" b="1">
                 <a:solidFill>
                   <a:srgbClr val="1A1F2B"/>
                 </a:solidFill>
                 <a:latin typeface="Calibri"/>
               </a:rPr>
-              <a:t>SecureCoating-Vision</a:t>
-            </a:r>
-          </a:p>
-        </p:txBody>
-      </p:sp>
-      <p:sp>
-        <p:nvSpPr>
-          <p:cNvPr id="7" name="TextBox 6"/>
+              <a:t>SecureCoating Vision</a:t>
+            </a:r>
+          </a:p>
+        </p:txBody>
+      </p:sp>
+      <p:sp>
+        <p:nvSpPr>
+          <p:cNvPr id="6" name="TextBox 5"/>
           <p:cNvSpPr txBox="1"/>
           <p:nvPr/>
         </p:nvSpPr>
         <p:spPr>
           <a:xfrm>
-            <a:off x="411480" y="1783080"/>
+            <a:off x="411480" y="1417320"/>
             <a:ext cx="11338560" cy="1234440"/>
           </a:xfrm>
           <a:prstGeom prst="rect">
@@ -3343,7 +3287,7 @@
               </a:spcAft>
             </a:pPr>
             <a:r>
-              <a:rPr sz="1800" b="1">
+              <a:rPr sz="1700" b="1">
                 <a:solidFill>
                   <a:srgbClr val="1A1F2B"/>
                 </a:solidFill>
@@ -3356,13 +3300,13 @@
       </p:sp>
       <p:sp>
         <p:nvSpPr>
-          <p:cNvPr id="8" name="TextBox 7"/>
+          <p:cNvPr id="7" name="TextBox 6"/>
           <p:cNvSpPr txBox="1"/>
           <p:nvPr/>
         </p:nvSpPr>
         <p:spPr>
           <a:xfrm>
-            <a:off x="411480" y="3063240"/>
+            <a:off x="411480" y="2788920"/>
             <a:ext cx="11338560" cy="365760"/>
           </a:xfrm>
           <a:prstGeom prst="rect">
@@ -3395,13 +3339,13 @@
       </p:sp>
       <p:sp>
         <p:nvSpPr>
-          <p:cNvPr id="9" name="Rectangle 8"/>
+          <p:cNvPr id="8" name="Rectangle 7"/>
           <p:cNvSpPr/>
           <p:nvPr/>
         </p:nvSpPr>
         <p:spPr>
           <a:xfrm>
-            <a:off x="411480" y="3520440"/>
+            <a:off x="411480" y="3246120"/>
             <a:ext cx="11338560" cy="12700"/>
           </a:xfrm>
           <a:prstGeom prst="rect">
@@ -3438,102 +3382,14 @@
       </p:sp>
       <p:sp>
         <p:nvSpPr>
-          <p:cNvPr id="10" name="Rectangle 9"/>
-          <p:cNvSpPr/>
-          <p:nvPr/>
-        </p:nvSpPr>
-        <p:spPr>
-          <a:xfrm>
-            <a:off x="411480" y="3749039"/>
-            <a:ext cx="5532120" cy="868680"/>
-          </a:xfrm>
-          <a:prstGeom prst="rect">
-            <a:avLst/>
-          </a:prstGeom>
-          <a:solidFill>
-            <a:srgbClr val="F4F7FB"/>
-          </a:solidFill>
-          <a:ln w="6350">
-            <a:solidFill>
-              <a:srgbClr val="D5DCE6"/>
-            </a:solidFill>
-          </a:ln>
-        </p:spPr>
-        <p:style>
-          <a:lnRef idx="1">
-            <a:schemeClr val="accent1"/>
-          </a:lnRef>
-          <a:fillRef idx="3">
-            <a:schemeClr val="accent1"/>
-          </a:fillRef>
-          <a:effectRef idx="2">
-            <a:schemeClr val="accent1"/>
-          </a:effectRef>
-          <a:fontRef idx="minor">
-            <a:schemeClr val="lt1"/>
-          </a:fontRef>
-        </p:style>
-        <p:txBody>
-          <a:bodyPr rtlCol="0" anchor="ctr"/>
-          <a:lstStyle/>
-          <a:p>
-            <a:pPr algn="ctr"/>
-          </a:p>
-        </p:txBody>
-      </p:sp>
-      <p:sp>
-        <p:nvSpPr>
-          <p:cNvPr id="11" name="Rectangle 10"/>
-          <p:cNvSpPr/>
-          <p:nvPr/>
-        </p:nvSpPr>
-        <p:spPr>
-          <a:xfrm>
-            <a:off x="411480" y="3749039"/>
-            <a:ext cx="73152" cy="868680"/>
-          </a:xfrm>
-          <a:prstGeom prst="rect">
-            <a:avLst/>
-          </a:prstGeom>
-          <a:solidFill>
-            <a:srgbClr val="1F5EB8"/>
-          </a:solidFill>
-          <a:ln>
-            <a:noFill/>
-          </a:ln>
-        </p:spPr>
-        <p:style>
-          <a:lnRef idx="1">
-            <a:schemeClr val="accent1"/>
-          </a:lnRef>
-          <a:fillRef idx="3">
-            <a:schemeClr val="accent1"/>
-          </a:fillRef>
-          <a:effectRef idx="2">
-            <a:schemeClr val="accent1"/>
-          </a:effectRef>
-          <a:fontRef idx="minor">
-            <a:schemeClr val="lt1"/>
-          </a:fontRef>
-        </p:style>
-        <p:txBody>
-          <a:bodyPr rtlCol="0" anchor="ctr"/>
-          <a:lstStyle/>
-          <a:p>
-            <a:pPr algn="ctr"/>
-          </a:p>
-        </p:txBody>
-      </p:sp>
-      <p:sp>
-        <p:nvSpPr>
-          <p:cNvPr id="12" name="TextBox 11"/>
+          <p:cNvPr id="9" name="TextBox 8"/>
           <p:cNvSpPr txBox="1"/>
           <p:nvPr/>
         </p:nvSpPr>
         <p:spPr>
           <a:xfrm>
-            <a:off x="640080" y="3840479"/>
-            <a:ext cx="5120640" cy="228600"/>
+            <a:off x="411480" y="3520440"/>
+            <a:ext cx="11338560" cy="822960"/>
           </a:xfrm>
           <a:prstGeom prst="rect">
             <a:avLst/>
@@ -3548,31 +3404,63 @@
           <a:p>
             <a:pPr algn="l">
               <a:spcAft>
+                <a:spcPts val="800"/>
+              </a:spcAft>
+            </a:pPr>
+            <a:r>
+              <a:rPr sz="1800" b="1">
+                <a:solidFill>
+                  <a:srgbClr val="1A1F2B"/>
+                </a:solidFill>
+                <a:latin typeface="Calibri"/>
+              </a:rPr>
+              <a:t>Team 71 · Track 4 — AI + Materials Testing &amp; Characterization</a:t>
+            </a:r>
+          </a:p>
+          <a:p>
+            <a:pPr algn="l">
+              <a:spcAft>
+                <a:spcPts val="1000"/>
+              </a:spcAft>
+            </a:pPr>
+            <a:r>
+              <a:rPr sz="1800" b="1">
+                <a:solidFill>
+                  <a:srgbClr val="1A1F2B"/>
+                </a:solidFill>
+                <a:latin typeface="Calibri"/>
+              </a:rPr>
+              <a:t>Trinh Hoang Tu · HUFLIT</a:t>
+            </a:r>
+          </a:p>
+          <a:p>
+            <a:pPr algn="l">
+              <a:spcAft>
                 <a:spcPts val="600"/>
               </a:spcAft>
             </a:pPr>
             <a:r>
-              <a:rPr sz="1100" b="1">
+              <a:rPr sz="1300" b="0">
                 <a:solidFill>
                   <a:srgbClr val="5C6775"/>
                 </a:solidFill>
                 <a:latin typeface="Calibri"/>
               </a:rPr>
-              <a:t>TEAM</a:t>
-            </a:r>
-          </a:p>
-        </p:txBody>
-      </p:sp>
-      <p:sp>
-        <p:nvSpPr>
-          <p:cNvPr id="13" name="TextBox 12"/>
+              <a:t>Advisor: Prof. Kris Singh · Visiting Professor, Tsinghua University · Founder &amp; CEO, SRII</a:t>
+            </a:r>
+          </a:p>
+        </p:txBody>
+      </p:sp>
+      <p:sp>
+        <p:nvSpPr>
+          <p:cNvPr id="10" name="TextBox 9"/>
           <p:cNvSpPr txBox="1"/>
           <p:nvPr/>
         </p:nvSpPr>
         <p:spPr>
           <a:xfrm>
-            <a:off x="640080" y="4114799"/>
-            <a:ext cx="5120640" cy="365760"/>
+            <a:off x="411480" y="5074920"/>
+            <a:ext cx="11338560" cy="1005840"/>
           </a:xfrm>
           <a:prstGeom prst="rect">
             <a:avLst/>
@@ -3587,119 +3475,47 @@
           <a:p>
             <a:pPr algn="l">
               <a:spcAft>
+                <a:spcPts val="800"/>
+              </a:spcAft>
+            </a:pPr>
+            <a:r>
+              <a:rPr sz="1400" b="0">
+                <a:solidFill>
+                  <a:srgbClr val="5C6775"/>
+                </a:solidFill>
+                <a:latin typeface="Calibri"/>
+              </a:rPr>
+              <a:t>Registered title describes the target Zero-Trust Edge-Cloud architecture. This prototype validates inspection, evidence gating, and fail-closed contracts — not completed mTLS/RBAC/OT or factory qualification.</a:t>
+            </a:r>
+          </a:p>
+          <a:p>
+            <a:pPr algn="l">
+              <a:spcAft>
                 <a:spcPts val="600"/>
               </a:spcAft>
             </a:pPr>
             <a:r>
-              <a:rPr sz="1600" b="1">
-                <a:solidFill>
-                  <a:srgbClr val="1A1F2B"/>
-                </a:solidFill>
-                <a:latin typeface="Calibri"/>
-              </a:rPr>
-              <a:t>71  ·  Trịnh Hoàng Tú</a:t>
-            </a:r>
-          </a:p>
-        </p:txBody>
-      </p:sp>
-      <p:sp>
-        <p:nvSpPr>
-          <p:cNvPr id="14" name="Rectangle 13"/>
-          <p:cNvSpPr/>
-          <p:nvPr/>
-        </p:nvSpPr>
-        <p:spPr>
-          <a:xfrm>
-            <a:off x="6172200" y="3749039"/>
-            <a:ext cx="5532120" cy="868680"/>
-          </a:xfrm>
-          <a:prstGeom prst="rect">
-            <a:avLst/>
-          </a:prstGeom>
-          <a:solidFill>
-            <a:srgbClr val="F4F7FB"/>
-          </a:solidFill>
-          <a:ln w="6350">
-            <a:solidFill>
-              <a:srgbClr val="D5DCE6"/>
-            </a:solidFill>
-          </a:ln>
-        </p:spPr>
-        <p:style>
-          <a:lnRef idx="1">
-            <a:schemeClr val="accent1"/>
-          </a:lnRef>
-          <a:fillRef idx="3">
-            <a:schemeClr val="accent1"/>
-          </a:fillRef>
-          <a:effectRef idx="2">
-            <a:schemeClr val="accent1"/>
-          </a:effectRef>
-          <a:fontRef idx="minor">
-            <a:schemeClr val="lt1"/>
-          </a:fontRef>
-        </p:style>
-        <p:txBody>
-          <a:bodyPr rtlCol="0" anchor="ctr"/>
-          <a:lstStyle/>
-          <a:p>
-            <a:pPr algn="ctr"/>
-          </a:p>
-        </p:txBody>
-      </p:sp>
-      <p:sp>
-        <p:nvSpPr>
-          <p:cNvPr id="15" name="Rectangle 14"/>
-          <p:cNvSpPr/>
-          <p:nvPr/>
-        </p:nvSpPr>
-        <p:spPr>
-          <a:xfrm>
-            <a:off x="6172200" y="3749039"/>
-            <a:ext cx="73152" cy="868680"/>
-          </a:xfrm>
-          <a:prstGeom prst="rect">
-            <a:avLst/>
-          </a:prstGeom>
-          <a:solidFill>
-            <a:srgbClr val="1F5EB8"/>
-          </a:solidFill>
-          <a:ln>
-            <a:noFill/>
-          </a:ln>
-        </p:spPr>
-        <p:style>
-          <a:lnRef idx="1">
-            <a:schemeClr val="accent1"/>
-          </a:lnRef>
-          <a:fillRef idx="3">
-            <a:schemeClr val="accent1"/>
-          </a:fillRef>
-          <a:effectRef idx="2">
-            <a:schemeClr val="accent1"/>
-          </a:effectRef>
-          <a:fontRef idx="minor">
-            <a:schemeClr val="lt1"/>
-          </a:fontRef>
-        </p:style>
-        <p:txBody>
-          <a:bodyPr rtlCol="0" anchor="ctr"/>
-          <a:lstStyle/>
-          <a:p>
-            <a:pPr algn="ctr"/>
-          </a:p>
-        </p:txBody>
-      </p:sp>
-      <p:sp>
-        <p:nvSpPr>
-          <p:cNvPr id="16" name="TextBox 15"/>
+              <a:rPr sz="1400" b="0">
+                <a:solidFill>
+                  <a:srgbClr val="5C6775"/>
+                </a:solidFill>
+                <a:latin typeface="Calibri"/>
+              </a:rPr>
+              <a:t>Decision objective: prove a defensible inline inspection architecture. Supervised factory pilot is the next gate.</a:t>
+            </a:r>
+          </a:p>
+        </p:txBody>
+      </p:sp>
+      <p:sp>
+        <p:nvSpPr>
+          <p:cNvPr id="11" name="TextBox 10"/>
           <p:cNvSpPr txBox="1"/>
           <p:nvPr/>
         </p:nvSpPr>
         <p:spPr>
           <a:xfrm>
-            <a:off x="6400800" y="3840479"/>
-            <a:ext cx="5120640" cy="228600"/>
+            <a:off x="411480" y="6510528"/>
+            <a:ext cx="7772400" cy="256032"/>
           </a:xfrm>
           <a:prstGeom prst="rect">
             <a:avLst/>
@@ -3718,461 +3534,12 @@
               </a:spcAft>
             </a:pPr>
             <a:r>
-              <a:rPr sz="1100" b="1">
+              <a:rPr sz="1100" b="0">
                 <a:solidFill>
                   <a:srgbClr val="5C6775"/>
                 </a:solidFill>
                 <a:latin typeface="Calibri"/>
               </a:rPr>
-              <a:t>AFFILIATION</a:t>
-            </a:r>
-          </a:p>
-        </p:txBody>
-      </p:sp>
-      <p:sp>
-        <p:nvSpPr>
-          <p:cNvPr id="17" name="TextBox 16"/>
-          <p:cNvSpPr txBox="1"/>
-          <p:nvPr/>
-        </p:nvSpPr>
-        <p:spPr>
-          <a:xfrm>
-            <a:off x="6400800" y="4114799"/>
-            <a:ext cx="5120640" cy="365760"/>
-          </a:xfrm>
-          <a:prstGeom prst="rect">
-            <a:avLst/>
-          </a:prstGeom>
-          <a:noFill/>
-        </p:spPr>
-        <p:txBody>
-          <a:bodyPr wrap="square">
-            <a:spAutoFit/>
-          </a:bodyPr>
-          <a:lstStyle/>
-          <a:p>
-            <a:pPr algn="l">
-              <a:spcAft>
-                <a:spcPts val="600"/>
-              </a:spcAft>
-            </a:pPr>
-            <a:r>
-              <a:rPr sz="1600" b="1">
-                <a:solidFill>
-                  <a:srgbClr val="1A1F2B"/>
-                </a:solidFill>
-                <a:latin typeface="Calibri"/>
-              </a:rPr>
-              <a:t>HUFLIT</a:t>
-            </a:r>
-          </a:p>
-        </p:txBody>
-      </p:sp>
-      <p:sp>
-        <p:nvSpPr>
-          <p:cNvPr id="18" name="Rectangle 17"/>
-          <p:cNvSpPr/>
-          <p:nvPr/>
-        </p:nvSpPr>
-        <p:spPr>
-          <a:xfrm>
-            <a:off x="411480" y="4754879"/>
-            <a:ext cx="5532120" cy="868680"/>
-          </a:xfrm>
-          <a:prstGeom prst="rect">
-            <a:avLst/>
-          </a:prstGeom>
-          <a:solidFill>
-            <a:srgbClr val="F4F7FB"/>
-          </a:solidFill>
-          <a:ln w="6350">
-            <a:solidFill>
-              <a:srgbClr val="D5DCE6"/>
-            </a:solidFill>
-          </a:ln>
-        </p:spPr>
-        <p:style>
-          <a:lnRef idx="1">
-            <a:schemeClr val="accent1"/>
-          </a:lnRef>
-          <a:fillRef idx="3">
-            <a:schemeClr val="accent1"/>
-          </a:fillRef>
-          <a:effectRef idx="2">
-            <a:schemeClr val="accent1"/>
-          </a:effectRef>
-          <a:fontRef idx="minor">
-            <a:schemeClr val="lt1"/>
-          </a:fontRef>
-        </p:style>
-        <p:txBody>
-          <a:bodyPr rtlCol="0" anchor="ctr"/>
-          <a:lstStyle/>
-          <a:p>
-            <a:pPr algn="ctr"/>
-          </a:p>
-        </p:txBody>
-      </p:sp>
-      <p:sp>
-        <p:nvSpPr>
-          <p:cNvPr id="19" name="Rectangle 18"/>
-          <p:cNvSpPr/>
-          <p:nvPr/>
-        </p:nvSpPr>
-        <p:spPr>
-          <a:xfrm>
-            <a:off x="411480" y="4754879"/>
-            <a:ext cx="73152" cy="868680"/>
-          </a:xfrm>
-          <a:prstGeom prst="rect">
-            <a:avLst/>
-          </a:prstGeom>
-          <a:solidFill>
-            <a:srgbClr val="1F5EB8"/>
-          </a:solidFill>
-          <a:ln>
-            <a:noFill/>
-          </a:ln>
-        </p:spPr>
-        <p:style>
-          <a:lnRef idx="1">
-            <a:schemeClr val="accent1"/>
-          </a:lnRef>
-          <a:fillRef idx="3">
-            <a:schemeClr val="accent1"/>
-          </a:fillRef>
-          <a:effectRef idx="2">
-            <a:schemeClr val="accent1"/>
-          </a:effectRef>
-          <a:fontRef idx="minor">
-            <a:schemeClr val="lt1"/>
-          </a:fontRef>
-        </p:style>
-        <p:txBody>
-          <a:bodyPr rtlCol="0" anchor="ctr"/>
-          <a:lstStyle/>
-          <a:p>
-            <a:pPr algn="ctr"/>
-          </a:p>
-        </p:txBody>
-      </p:sp>
-      <p:sp>
-        <p:nvSpPr>
-          <p:cNvPr id="20" name="TextBox 19"/>
-          <p:cNvSpPr txBox="1"/>
-          <p:nvPr/>
-        </p:nvSpPr>
-        <p:spPr>
-          <a:xfrm>
-            <a:off x="640080" y="4846319"/>
-            <a:ext cx="5120640" cy="228600"/>
-          </a:xfrm>
-          <a:prstGeom prst="rect">
-            <a:avLst/>
-          </a:prstGeom>
-          <a:noFill/>
-        </p:spPr>
-        <p:txBody>
-          <a:bodyPr wrap="square">
-            <a:spAutoFit/>
-          </a:bodyPr>
-          <a:lstStyle/>
-          <a:p>
-            <a:pPr algn="l">
-              <a:spcAft>
-                <a:spcPts val="600"/>
-              </a:spcAft>
-            </a:pPr>
-            <a:r>
-              <a:rPr sz="1100" b="1">
-                <a:solidFill>
-                  <a:srgbClr val="5C6775"/>
-                </a:solidFill>
-                <a:latin typeface="Calibri"/>
-              </a:rPr>
-              <a:t>TRACK</a:t>
-            </a:r>
-          </a:p>
-        </p:txBody>
-      </p:sp>
-      <p:sp>
-        <p:nvSpPr>
-          <p:cNvPr id="21" name="TextBox 20"/>
-          <p:cNvSpPr txBox="1"/>
-          <p:nvPr/>
-        </p:nvSpPr>
-        <p:spPr>
-          <a:xfrm>
-            <a:off x="640080" y="5120639"/>
-            <a:ext cx="5120640" cy="365760"/>
-          </a:xfrm>
-          <a:prstGeom prst="rect">
-            <a:avLst/>
-          </a:prstGeom>
-          <a:noFill/>
-        </p:spPr>
-        <p:txBody>
-          <a:bodyPr wrap="square">
-            <a:spAutoFit/>
-          </a:bodyPr>
-          <a:lstStyle/>
-          <a:p>
-            <a:pPr algn="l">
-              <a:spcAft>
-                <a:spcPts val="600"/>
-              </a:spcAft>
-            </a:pPr>
-            <a:r>
-              <a:rPr sz="1600" b="1">
-                <a:solidFill>
-                  <a:srgbClr val="1A1F2B"/>
-                </a:solidFill>
-                <a:latin typeface="Calibri"/>
-              </a:rPr>
-              <a:t>4  ·  AI + Materials Testing and Characterization</a:t>
-            </a:r>
-          </a:p>
-        </p:txBody>
-      </p:sp>
-      <p:sp>
-        <p:nvSpPr>
-          <p:cNvPr id="22" name="Rectangle 21"/>
-          <p:cNvSpPr/>
-          <p:nvPr/>
-        </p:nvSpPr>
-        <p:spPr>
-          <a:xfrm>
-            <a:off x="6172200" y="4754879"/>
-            <a:ext cx="5532120" cy="868680"/>
-          </a:xfrm>
-          <a:prstGeom prst="rect">
-            <a:avLst/>
-          </a:prstGeom>
-          <a:solidFill>
-            <a:srgbClr val="F4F7FB"/>
-          </a:solidFill>
-          <a:ln w="6350">
-            <a:solidFill>
-              <a:srgbClr val="D5DCE6"/>
-            </a:solidFill>
-          </a:ln>
-        </p:spPr>
-        <p:style>
-          <a:lnRef idx="1">
-            <a:schemeClr val="accent1"/>
-          </a:lnRef>
-          <a:fillRef idx="3">
-            <a:schemeClr val="accent1"/>
-          </a:fillRef>
-          <a:effectRef idx="2">
-            <a:schemeClr val="accent1"/>
-          </a:effectRef>
-          <a:fontRef idx="minor">
-            <a:schemeClr val="lt1"/>
-          </a:fontRef>
-        </p:style>
-        <p:txBody>
-          <a:bodyPr rtlCol="0" anchor="ctr"/>
-          <a:lstStyle/>
-          <a:p>
-            <a:pPr algn="ctr"/>
-          </a:p>
-        </p:txBody>
-      </p:sp>
-      <p:sp>
-        <p:nvSpPr>
-          <p:cNvPr id="23" name="Rectangle 22"/>
-          <p:cNvSpPr/>
-          <p:nvPr/>
-        </p:nvSpPr>
-        <p:spPr>
-          <a:xfrm>
-            <a:off x="6172200" y="4754879"/>
-            <a:ext cx="73152" cy="868680"/>
-          </a:xfrm>
-          <a:prstGeom prst="rect">
-            <a:avLst/>
-          </a:prstGeom>
-          <a:solidFill>
-            <a:srgbClr val="1F5EB8"/>
-          </a:solidFill>
-          <a:ln>
-            <a:noFill/>
-          </a:ln>
-        </p:spPr>
-        <p:style>
-          <a:lnRef idx="1">
-            <a:schemeClr val="accent1"/>
-          </a:lnRef>
-          <a:fillRef idx="3">
-            <a:schemeClr val="accent1"/>
-          </a:fillRef>
-          <a:effectRef idx="2">
-            <a:schemeClr val="accent1"/>
-          </a:effectRef>
-          <a:fontRef idx="minor">
-            <a:schemeClr val="lt1"/>
-          </a:fontRef>
-        </p:style>
-        <p:txBody>
-          <a:bodyPr rtlCol="0" anchor="ctr"/>
-          <a:lstStyle/>
-          <a:p>
-            <a:pPr algn="ctr"/>
-          </a:p>
-        </p:txBody>
-      </p:sp>
-      <p:sp>
-        <p:nvSpPr>
-          <p:cNvPr id="24" name="TextBox 23"/>
-          <p:cNvSpPr txBox="1"/>
-          <p:nvPr/>
-        </p:nvSpPr>
-        <p:spPr>
-          <a:xfrm>
-            <a:off x="6400800" y="4846319"/>
-            <a:ext cx="5120640" cy="228600"/>
-          </a:xfrm>
-          <a:prstGeom prst="rect">
-            <a:avLst/>
-          </a:prstGeom>
-          <a:noFill/>
-        </p:spPr>
-        <p:txBody>
-          <a:bodyPr wrap="square">
-            <a:spAutoFit/>
-          </a:bodyPr>
-          <a:lstStyle/>
-          <a:p>
-            <a:pPr algn="l">
-              <a:spcAft>
-                <a:spcPts val="600"/>
-              </a:spcAft>
-            </a:pPr>
-            <a:r>
-              <a:rPr sz="1100" b="1">
-                <a:solidFill>
-                  <a:srgbClr val="5C6775"/>
-                </a:solidFill>
-                <a:latin typeface="Calibri"/>
-              </a:rPr>
-              <a:t>ADVISOR</a:t>
-            </a:r>
-          </a:p>
-        </p:txBody>
-      </p:sp>
-      <p:sp>
-        <p:nvSpPr>
-          <p:cNvPr id="25" name="TextBox 24"/>
-          <p:cNvSpPr txBox="1"/>
-          <p:nvPr/>
-        </p:nvSpPr>
-        <p:spPr>
-          <a:xfrm>
-            <a:off x="6400800" y="5120639"/>
-            <a:ext cx="5120640" cy="365760"/>
-          </a:xfrm>
-          <a:prstGeom prst="rect">
-            <a:avLst/>
-          </a:prstGeom>
-          <a:noFill/>
-        </p:spPr>
-        <p:txBody>
-          <a:bodyPr wrap="square">
-            <a:spAutoFit/>
-          </a:bodyPr>
-          <a:lstStyle/>
-          <a:p>
-            <a:pPr algn="l">
-              <a:spcAft>
-                <a:spcPts val="600"/>
-              </a:spcAft>
-            </a:pPr>
-            <a:r>
-              <a:rPr sz="1600" b="1">
-                <a:solidFill>
-                  <a:srgbClr val="1A1F2B"/>
-                </a:solidFill>
-                <a:latin typeface="Calibri"/>
-              </a:rPr>
-              <a:t>Prof. Kris Singh  ·  SRII / Tsinghua (visiting)</a:t>
-            </a:r>
-          </a:p>
-        </p:txBody>
-      </p:sp>
-      <p:sp>
-        <p:nvSpPr>
-          <p:cNvPr id="26" name="TextBox 25"/>
-          <p:cNvSpPr txBox="1"/>
-          <p:nvPr/>
-        </p:nvSpPr>
-        <p:spPr>
-          <a:xfrm>
-            <a:off x="411480" y="5852160"/>
-            <a:ext cx="11338560" cy="457200"/>
-          </a:xfrm>
-          <a:prstGeom prst="rect">
-            <a:avLst/>
-          </a:prstGeom>
-          <a:noFill/>
-        </p:spPr>
-        <p:txBody>
-          <a:bodyPr wrap="square">
-            <a:spAutoFit/>
-          </a:bodyPr>
-          <a:lstStyle/>
-          <a:p>
-            <a:pPr algn="l">
-              <a:spcAft>
-                <a:spcPts val="600"/>
-              </a:spcAft>
-            </a:pPr>
-            <a:r>
-              <a:rPr sz="1400" b="0">
-                <a:solidFill>
-                  <a:srgbClr val="5C6775"/>
-                </a:solidFill>
-                <a:latin typeface="Calibri"/>
-              </a:rPr>
-              <a:t>Decision objective: prove a defensible inline inspection architecture. Supervised factory pilot is the next gate.</a:t>
-            </a:r>
-          </a:p>
-        </p:txBody>
-      </p:sp>
-      <p:sp>
-        <p:nvSpPr>
-          <p:cNvPr id="27" name="TextBox 26"/>
-          <p:cNvSpPr txBox="1"/>
-          <p:nvPr/>
-        </p:nvSpPr>
-        <p:spPr>
-          <a:xfrm>
-            <a:off x="411480" y="6510528"/>
-            <a:ext cx="7772400" cy="256032"/>
-          </a:xfrm>
-          <a:prstGeom prst="rect">
-            <a:avLst/>
-          </a:prstGeom>
-          <a:noFill/>
-        </p:spPr>
-        <p:txBody>
-          <a:bodyPr wrap="square">
-            <a:spAutoFit/>
-          </a:bodyPr>
-          <a:lstStyle/>
-          <a:p>
-            <a:pPr algn="l">
-              <a:spcAft>
-                <a:spcPts val="600"/>
-              </a:spcAft>
-            </a:pPr>
-            <a:r>
-              <a:rPr sz="1100" b="0">
-                <a:solidFill>
-                  <a:srgbClr val="5C6775"/>
-                </a:solidFill>
-                <a:latin typeface="Calibri"/>
-              </a:rPr>
               <a:t>Team 71  ·  Trịnh Hoàng Tú  ·  HUFLIT  ·  Track 4</a:t>
             </a:r>
           </a:p>
@@ -4180,7 +3547,7 @@
       </p:sp>
       <p:sp>
         <p:nvSpPr>
-          <p:cNvPr id="28" name="TextBox 27"/>
+          <p:cNvPr id="12" name="TextBox 11"/>
           <p:cNvSpPr txBox="1"/>
           <p:nvPr/>
         </p:nvSpPr>

</xml_diff>

<commit_message>
Align final form, proposal identity, and Track 4 speed evidence.
Place advisor only in Application Form Section 6, add Inspection_System_Proposal, replace internal TODO status with Final Submission Status, and surface CPU inference ms on Slide 7 without claiming line throughput.

Co-authored-by: Cursor <cursoragent@cursor.com>
</commit_message>
<xml_diff>
--- a/SecureCoating-Vision_Final_Defense_6min.pptx
+++ b/SecureCoating-Vision_Final_Defense_6min.pptx
@@ -8386,8 +8386,8 @@
         </p:nvSpPr>
         <p:spPr>
           <a:xfrm>
-            <a:off x="411480" y="1417320"/>
-            <a:ext cx="2743200" cy="1965960"/>
+            <a:off x="411480" y="1325880"/>
+            <a:ext cx="2743200" cy="1783080"/>
           </a:xfrm>
           <a:prstGeom prst="rect">
             <a:avLst/>
@@ -8431,8 +8431,8 @@
         </p:nvSpPr>
         <p:spPr>
           <a:xfrm>
-            <a:off x="411480" y="1417320"/>
-            <a:ext cx="73152" cy="1965960"/>
+            <a:off x="411480" y="1325880"/>
+            <a:ext cx="73152" cy="1783080"/>
           </a:xfrm>
           <a:prstGeom prst="rect">
             <a:avLst/>
@@ -8474,8 +8474,8 @@
         </p:nvSpPr>
         <p:spPr>
           <a:xfrm>
-            <a:off x="548640" y="1536192"/>
-            <a:ext cx="2468880" cy="274320"/>
+            <a:off x="548640" y="1417320"/>
+            <a:ext cx="2468880" cy="256032"/>
           </a:xfrm>
           <a:prstGeom prst="rect">
             <a:avLst/>
@@ -8513,8 +8513,8 @@
         </p:nvSpPr>
         <p:spPr>
           <a:xfrm>
-            <a:off x="548640" y="1874519"/>
-            <a:ext cx="2468880" cy="502920"/>
+            <a:off x="548640" y="1737360"/>
+            <a:ext cx="2468880" cy="457200"/>
           </a:xfrm>
           <a:prstGeom prst="rect">
             <a:avLst/>
@@ -8533,7 +8533,7 @@
               </a:spcAft>
             </a:pPr>
             <a:r>
-              <a:rPr sz="2800" b="1">
+              <a:rPr sz="2600" b="1">
                 <a:solidFill>
                   <a:srgbClr val="1A1F2B"/>
                 </a:solidFill>
@@ -8552,7 +8552,7 @@
         </p:nvSpPr>
         <p:spPr>
           <a:xfrm>
-            <a:off x="548640" y="2468880"/>
+            <a:off x="548640" y="2286000"/>
             <a:ext cx="2468880" cy="640080"/>
           </a:xfrm>
           <a:prstGeom prst="rect">
@@ -8591,8 +8591,8 @@
         </p:nvSpPr>
         <p:spPr>
           <a:xfrm>
-            <a:off x="3291840" y="1417320"/>
-            <a:ext cx="2743200" cy="1965960"/>
+            <a:off x="3291840" y="1325880"/>
+            <a:ext cx="2743200" cy="1783080"/>
           </a:xfrm>
           <a:prstGeom prst="rect">
             <a:avLst/>
@@ -8636,8 +8636,8 @@
         </p:nvSpPr>
         <p:spPr>
           <a:xfrm>
-            <a:off x="3291840" y="1417320"/>
-            <a:ext cx="73152" cy="1965960"/>
+            <a:off x="3291840" y="1325880"/>
+            <a:ext cx="73152" cy="1783080"/>
           </a:xfrm>
           <a:prstGeom prst="rect">
             <a:avLst/>
@@ -8679,8 +8679,8 @@
         </p:nvSpPr>
         <p:spPr>
           <a:xfrm>
-            <a:off x="3429000" y="1536192"/>
-            <a:ext cx="2468880" cy="274320"/>
+            <a:off x="3429000" y="1417320"/>
+            <a:ext cx="2468880" cy="256032"/>
           </a:xfrm>
           <a:prstGeom prst="rect">
             <a:avLst/>
@@ -8718,8 +8718,8 @@
         </p:nvSpPr>
         <p:spPr>
           <a:xfrm>
-            <a:off x="3429000" y="1874519"/>
-            <a:ext cx="2468880" cy="502920"/>
+            <a:off x="3429000" y="1737360"/>
+            <a:ext cx="2468880" cy="457200"/>
           </a:xfrm>
           <a:prstGeom prst="rect">
             <a:avLst/>
@@ -8738,7 +8738,7 @@
               </a:spcAft>
             </a:pPr>
             <a:r>
-              <a:rPr sz="2800" b="1">
+              <a:rPr sz="2600" b="1">
                 <a:solidFill>
                   <a:srgbClr val="1A1F2B"/>
                 </a:solidFill>
@@ -8757,7 +8757,7 @@
         </p:nvSpPr>
         <p:spPr>
           <a:xfrm>
-            <a:off x="3429000" y="2468880"/>
+            <a:off x="3429000" y="2286000"/>
             <a:ext cx="2468880" cy="640080"/>
           </a:xfrm>
           <a:prstGeom prst="rect">
@@ -8796,8 +8796,8 @@
         </p:nvSpPr>
         <p:spPr>
           <a:xfrm>
-            <a:off x="6172200" y="1417320"/>
-            <a:ext cx="2743200" cy="1965960"/>
+            <a:off x="6172200" y="1325880"/>
+            <a:ext cx="2743200" cy="1783080"/>
           </a:xfrm>
           <a:prstGeom prst="rect">
             <a:avLst/>
@@ -8841,8 +8841,8 @@
         </p:nvSpPr>
         <p:spPr>
           <a:xfrm>
-            <a:off x="6172200" y="1417320"/>
-            <a:ext cx="73152" cy="1965960"/>
+            <a:off x="6172200" y="1325880"/>
+            <a:ext cx="73152" cy="1783080"/>
           </a:xfrm>
           <a:prstGeom prst="rect">
             <a:avLst/>
@@ -8884,8 +8884,8 @@
         </p:nvSpPr>
         <p:spPr>
           <a:xfrm>
-            <a:off x="6309360" y="1536192"/>
-            <a:ext cx="2468880" cy="274320"/>
+            <a:off x="6309360" y="1417320"/>
+            <a:ext cx="2468880" cy="256032"/>
           </a:xfrm>
           <a:prstGeom prst="rect">
             <a:avLst/>
@@ -8923,8 +8923,8 @@
         </p:nvSpPr>
         <p:spPr>
           <a:xfrm>
-            <a:off x="6309360" y="1874519"/>
-            <a:ext cx="2468880" cy="502920"/>
+            <a:off x="6309360" y="1737360"/>
+            <a:ext cx="2468880" cy="457200"/>
           </a:xfrm>
           <a:prstGeom prst="rect">
             <a:avLst/>
@@ -8943,7 +8943,7 @@
               </a:spcAft>
             </a:pPr>
             <a:r>
-              <a:rPr sz="2800" b="1">
+              <a:rPr sz="2600" b="1">
                 <a:solidFill>
                   <a:srgbClr val="1A1F2B"/>
                 </a:solidFill>
@@ -8962,7 +8962,7 @@
         </p:nvSpPr>
         <p:spPr>
           <a:xfrm>
-            <a:off x="6309360" y="2468880"/>
+            <a:off x="6309360" y="2286000"/>
             <a:ext cx="2468880" cy="640080"/>
           </a:xfrm>
           <a:prstGeom prst="rect">
@@ -9001,8 +9001,8 @@
         </p:nvSpPr>
         <p:spPr>
           <a:xfrm>
-            <a:off x="9052559" y="1417320"/>
-            <a:ext cx="2743200" cy="1965960"/>
+            <a:off x="9052559" y="1325880"/>
+            <a:ext cx="2743200" cy="1783080"/>
           </a:xfrm>
           <a:prstGeom prst="rect">
             <a:avLst/>
@@ -9046,8 +9046,8 @@
         </p:nvSpPr>
         <p:spPr>
           <a:xfrm>
-            <a:off x="9052559" y="1417320"/>
-            <a:ext cx="73152" cy="1965960"/>
+            <a:off x="9052559" y="1325880"/>
+            <a:ext cx="73152" cy="1783080"/>
           </a:xfrm>
           <a:prstGeom prst="rect">
             <a:avLst/>
@@ -9089,8 +9089,8 @@
         </p:nvSpPr>
         <p:spPr>
           <a:xfrm>
-            <a:off x="9189719" y="1536192"/>
-            <a:ext cx="2468880" cy="274320"/>
+            <a:off x="9189719" y="1417320"/>
+            <a:ext cx="2468880" cy="256032"/>
           </a:xfrm>
           <a:prstGeom prst="rect">
             <a:avLst/>
@@ -9128,8 +9128,8 @@
         </p:nvSpPr>
         <p:spPr>
           <a:xfrm>
-            <a:off x="9189719" y="1874519"/>
-            <a:ext cx="2468880" cy="502920"/>
+            <a:off x="9189719" y="1737360"/>
+            <a:ext cx="2468880" cy="457200"/>
           </a:xfrm>
           <a:prstGeom prst="rect">
             <a:avLst/>
@@ -9148,7 +9148,7 @@
               </a:spcAft>
             </a:pPr>
             <a:r>
-              <a:rPr sz="2800" b="1">
+              <a:rPr sz="2600" b="1">
                 <a:solidFill>
                   <a:srgbClr val="C47B00"/>
                 </a:solidFill>
@@ -9167,7 +9167,7 @@
         </p:nvSpPr>
         <p:spPr>
           <a:xfrm>
-            <a:off x="9189719" y="2468880"/>
+            <a:off x="9189719" y="2286000"/>
             <a:ext cx="2468880" cy="640080"/>
           </a:xfrm>
           <a:prstGeom prst="rect">
@@ -9206,8 +9206,8 @@
         </p:nvSpPr>
         <p:spPr>
           <a:xfrm>
-            <a:off x="411480" y="3611880"/>
-            <a:ext cx="11338560" cy="2514600"/>
+            <a:off x="411480" y="3246120"/>
+            <a:ext cx="11338560" cy="960120"/>
           </a:xfrm>
           <a:prstGeom prst="rect">
             <a:avLst/>
@@ -9251,8 +9251,8 @@
         </p:nvSpPr>
         <p:spPr>
           <a:xfrm>
-            <a:off x="411480" y="3611880"/>
-            <a:ext cx="73152" cy="2514600"/>
+            <a:off x="411480" y="3246120"/>
+            <a:ext cx="73152" cy="960120"/>
           </a:xfrm>
           <a:prstGeom prst="rect">
             <a:avLst/>
@@ -9294,8 +9294,8 @@
         </p:nvSpPr>
         <p:spPr>
           <a:xfrm>
-            <a:off x="640080" y="3794760"/>
-            <a:ext cx="10972800" cy="2194560"/>
+            <a:off x="640080" y="3337560"/>
+            <a:ext cx="10972800" cy="777240"/>
           </a:xfrm>
           <a:prstGeom prst="rect">
             <a:avLst/>
@@ -9320,13 +9320,13 @@
                 </a:solidFill>
                 <a:latin typeface="Calibri"/>
               </a:rPr>
-              <a:t>EVIDENCE IDENTITY</a:t>
-            </a:r>
-          </a:p>
-          <a:p>
-            <a:pPr algn="l">
-              <a:spcAft>
-                <a:spcPts val="1000"/>
+              <a:t>INFERENCE</a:t>
+            </a:r>
+          </a:p>
+          <a:p>
+            <a:pPr algn="l">
+              <a:spcAft>
+                <a:spcPts val="600"/>
               </a:spcAft>
             </a:pPr>
             <a:r>
@@ -9336,37 +9336,109 @@
                 </a:solidFill>
                 <a:latin typeface="Calibri"/>
               </a:rPr>
-              <a:t>88 test images  ·  seed 71  ·  weights f72a8f2b…  ·  dataset d1db7823…</a:t>
-            </a:r>
-          </a:p>
-          <a:p>
-            <a:pPr algn="l">
-              <a:spcAft>
-                <a:spcPts val="600"/>
-              </a:spcAft>
-            </a:pPr>
-            <a:r>
-              <a:rPr sz="1500" b="0">
-                <a:solidFill>
-                  <a:srgbClr val="5C6775"/>
-                </a:solidFill>
-                <a:latin typeface="Calibri"/>
-              </a:rPr>
-              <a:t>Public real optical image-disjoint split. Not roll-disjoint; not factory qualification.</a:t>
-            </a:r>
-          </a:p>
-        </p:txBody>
-      </p:sp>
-      <p:sp>
-        <p:nvSpPr>
-          <p:cNvPr id="29" name="TextBox 28"/>
+              <a:t>21.6 ms/image  ·  CPU evaluation  ·  model inference only  ·  not factory-line throughput</a:t>
+            </a:r>
+          </a:p>
+        </p:txBody>
+      </p:sp>
+      <p:sp>
+        <p:nvSpPr>
+          <p:cNvPr id="29" name="Rectangle 28"/>
+          <p:cNvSpPr/>
+          <p:nvPr/>
+        </p:nvSpPr>
+        <p:spPr>
+          <a:xfrm>
+            <a:off x="411480" y="4343400"/>
+            <a:ext cx="11338560" cy="1783080"/>
+          </a:xfrm>
+          <a:prstGeom prst="rect">
+            <a:avLst/>
+          </a:prstGeom>
+          <a:solidFill>
+            <a:srgbClr val="F4F7FB"/>
+          </a:solidFill>
+          <a:ln w="6350">
+            <a:solidFill>
+              <a:srgbClr val="D5DCE6"/>
+            </a:solidFill>
+          </a:ln>
+        </p:spPr>
+        <p:style>
+          <a:lnRef idx="1">
+            <a:schemeClr val="accent1"/>
+          </a:lnRef>
+          <a:fillRef idx="3">
+            <a:schemeClr val="accent1"/>
+          </a:fillRef>
+          <a:effectRef idx="2">
+            <a:schemeClr val="accent1"/>
+          </a:effectRef>
+          <a:fontRef idx="minor">
+            <a:schemeClr val="lt1"/>
+          </a:fontRef>
+        </p:style>
+        <p:txBody>
+          <a:bodyPr rtlCol="0" anchor="ctr"/>
+          <a:lstStyle/>
+          <a:p>
+            <a:pPr algn="ctr"/>
+          </a:p>
+        </p:txBody>
+      </p:sp>
+      <p:sp>
+        <p:nvSpPr>
+          <p:cNvPr id="30" name="Rectangle 29"/>
+          <p:cNvSpPr/>
+          <p:nvPr/>
+        </p:nvSpPr>
+        <p:spPr>
+          <a:xfrm>
+            <a:off x="411480" y="4343400"/>
+            <a:ext cx="73152" cy="1783080"/>
+          </a:xfrm>
+          <a:prstGeom prst="rect">
+            <a:avLst/>
+          </a:prstGeom>
+          <a:solidFill>
+            <a:srgbClr val="1F5EB8"/>
+          </a:solidFill>
+          <a:ln>
+            <a:noFill/>
+          </a:ln>
+        </p:spPr>
+        <p:style>
+          <a:lnRef idx="1">
+            <a:schemeClr val="accent1"/>
+          </a:lnRef>
+          <a:fillRef idx="3">
+            <a:schemeClr val="accent1"/>
+          </a:fillRef>
+          <a:effectRef idx="2">
+            <a:schemeClr val="accent1"/>
+          </a:effectRef>
+          <a:fontRef idx="minor">
+            <a:schemeClr val="lt1"/>
+          </a:fontRef>
+        </p:style>
+        <p:txBody>
+          <a:bodyPr rtlCol="0" anchor="ctr"/>
+          <a:lstStyle/>
+          <a:p>
+            <a:pPr algn="ctr"/>
+          </a:p>
+        </p:txBody>
+      </p:sp>
+      <p:sp>
+        <p:nvSpPr>
+          <p:cNvPr id="31" name="TextBox 30"/>
           <p:cNvSpPr txBox="1"/>
           <p:nvPr/>
         </p:nvSpPr>
         <p:spPr>
           <a:xfrm>
-            <a:off x="411480" y="6510528"/>
-            <a:ext cx="7772400" cy="256032"/>
+            <a:off x="640080" y="4480560"/>
+            <a:ext cx="10972800" cy="1508760"/>
           </a:xfrm>
           <a:prstGeom prst="rect">
             <a:avLst/>
@@ -9385,6 +9457,77 @@
               </a:spcAft>
             </a:pPr>
             <a:r>
+              <a:rPr sz="1300" b="1">
+                <a:solidFill>
+                  <a:srgbClr val="1F5EB8"/>
+                </a:solidFill>
+                <a:latin typeface="Calibri"/>
+              </a:rPr>
+              <a:t>EVIDENCE IDENTITY</a:t>
+            </a:r>
+          </a:p>
+          <a:p>
+            <a:pPr algn="l">
+              <a:spcAft>
+                <a:spcPts val="800"/>
+              </a:spcAft>
+            </a:pPr>
+            <a:r>
+              <a:rPr sz="1700" b="1">
+                <a:solidFill>
+                  <a:srgbClr val="1A1F2B"/>
+                </a:solidFill>
+                <a:latin typeface="Calibri"/>
+              </a:rPr>
+              <a:t>88 test images  ·  seed 71  ·  weights f72a8f2b…  ·  dataset d1db7823…</a:t>
+            </a:r>
+          </a:p>
+          <a:p>
+            <a:pPr algn="l">
+              <a:spcAft>
+                <a:spcPts val="600"/>
+              </a:spcAft>
+            </a:pPr>
+            <a:r>
+              <a:rPr sz="1400" b="0">
+                <a:solidFill>
+                  <a:srgbClr val="5C6775"/>
+                </a:solidFill>
+                <a:latin typeface="Calibri"/>
+              </a:rPr>
+              <a:t>Public real optical image-disjoint split. Not roll-disjoint; not factory qualification. Timing excludes camera exposure, transport, and PLC ACK.</a:t>
+            </a:r>
+          </a:p>
+        </p:txBody>
+      </p:sp>
+      <p:sp>
+        <p:nvSpPr>
+          <p:cNvPr id="32" name="TextBox 31"/>
+          <p:cNvSpPr txBox="1"/>
+          <p:nvPr/>
+        </p:nvSpPr>
+        <p:spPr>
+          <a:xfrm>
+            <a:off x="411480" y="6510528"/>
+            <a:ext cx="7772400" cy="256032"/>
+          </a:xfrm>
+          <a:prstGeom prst="rect">
+            <a:avLst/>
+          </a:prstGeom>
+          <a:noFill/>
+        </p:spPr>
+        <p:txBody>
+          <a:bodyPr wrap="square">
+            <a:spAutoFit/>
+          </a:bodyPr>
+          <a:lstStyle/>
+          <a:p>
+            <a:pPr algn="l">
+              <a:spcAft>
+                <a:spcPts val="600"/>
+              </a:spcAft>
+            </a:pPr>
+            <a:r>
               <a:rPr sz="1100" b="0">
                 <a:solidFill>
                   <a:srgbClr val="5C6775"/>
@@ -9398,7 +9541,7 @@
       </p:sp>
       <p:sp>
         <p:nvSpPr>
-          <p:cNvPr id="30" name="TextBox 29"/>
+          <p:cNvPr id="33" name="TextBox 32"/>
           <p:cNvSpPr txBox="1"/>
           <p:nvPr/>
         </p:nvSpPr>

</xml_diff>

<commit_message>
Tighten claim wording for tests, RGB/LIBAD boundaries, and HMAC tags.
Restore Application Form section placement, drop stale LIBAD hash-verify next-steps, and keep Challenge 1 performance prediction as an explicit non-claim roadmap boundary.

Co-authored-by: Cursor <cursoragent@cursor.com>
</commit_message>
<xml_diff>
--- a/SecureCoating-Vision_Final_Defense_6min.pptx
+++ b/SecureCoating-Vision_Final_Defense_6min.pptx
@@ -3991,7 +3991,7 @@
                 </a:solidFill>
                 <a:latin typeface="Calibri"/>
               </a:rPr>
-              <a:t>Public CoatingVision image-disjoint split, seed 71. Not factory roll-disjoint; HIL and calibration remain pilot gates.</a:t>
+              <a:t>Public CoatingVision image-disjoint test split, seed 71; not factory roll-disjoint.</a:t>
             </a:r>
           </a:p>
         </p:txBody>
@@ -4518,7 +4518,7 @@
                 </a:solidFill>
                 <a:latin typeface="Calibri"/>
               </a:rPr>
-              <a:t>FastAPI  ·  SQLite PENDING→final  ·  OPC UA / Modbus command+ACK  ·  HMAC certificate</a:t>
+              <a:t>FastAPI  ·  SQLite PENDING→final  ·  OPC UA / Modbus command+ACK  ·  HMAC-SHA256 authenticated certificate</a:t>
             </a:r>
           </a:p>
           <a:p>
@@ -4677,7 +4677,7 @@
                 </a:solidFill>
                 <a:latin typeface="Calibri"/>
               </a:rPr>
-              <a:t>LIBAD VIS + X-rayL adapter</a:t>
+              <a:t>LIBAD VIS + X-rayL local adapter</a:t>
             </a:r>
           </a:p>
           <a:p>
@@ -4687,29 +4687,29 @@
               </a:spcAft>
             </a:pPr>
             <a:r>
+              <a:rPr sz="1400" b="0">
+                <a:solidFill>
+                  <a:srgbClr val="5C6775"/>
+                </a:solidFill>
+                <a:latin typeface="Calibri"/>
+              </a:rPr>
+              <a:t>Official mount hashed. Local numpy adapter mean multimodal AUROC 0.700 / FPR95 0.839 over 10 official splits — non-paper-comparable. Authors' DINOv2 interim (1 seed) ~AUROC 0.856 / FPR95 0.716; not paper DINOv3/DA-Core. Demo cases stay protocol fixtures.</a:t>
+            </a:r>
+          </a:p>
+          <a:p>
+            <a:pPr algn="l">
+              <a:spcAft>
+                <a:spcPts val="600"/>
+              </a:spcAft>
+            </a:pPr>
+            <a:r>
               <a:rPr sz="1500" b="0">
                 <a:solidFill>
-                  <a:srgbClr val="5C6775"/>
-                </a:solidFill>
-                <a:latin typeface="Calibri"/>
-              </a:rPr>
-              <a:t>Official mount hashed. Numpy 10-seed ~AUROC 0.70 / FPR95 0.84. Authors' runner interim DINOv2 (1 seed) ~AUROC 0.856 / FPR95 0.716 — still not paper DINOv3. Demo cases stay protocol fixtures.</a:t>
-            </a:r>
-          </a:p>
-          <a:p>
-            <a:pPr algn="l">
-              <a:spcAft>
-                <a:spcPts val="600"/>
-              </a:spcAft>
-            </a:pPr>
-            <a:r>
-              <a:rPr sz="1500" b="0">
-                <a:solidFill>
                   <a:srgbClr val="1F5EB8"/>
                 </a:solidFill>
                 <a:latin typeface="Calibri"/>
               </a:rPr>
-              <a:t>DA-Core is Sui et al. SecureCoating-Vision adds the evidence gate, not a new detector claim.</a:t>
+              <a:t>DA-Core is Sui et al. SecureCoating-Vision adds the evidence gate, not a paper reproduction claim.</a:t>
             </a:r>
           </a:p>
         </p:txBody>
@@ -7908,7 +7908,7 @@
                 </a:solidFill>
                 <a:latin typeface="Calibri"/>
               </a:rPr>
-              <a:t>HMAC-SHA256 over canonical payload</a:t>
+              <a:t>HMAC-SHA256 authenticated tag over canonical payload</a:t>
             </a:r>
           </a:p>
         </p:txBody>

</xml_diff>

<commit_message>
Sync competition title to organizer-approved Evidence-Gated Multimodal AI Work Title.
Align identity config, docs, Application Form wording, defense deck, LIBAD demos, and tests so release artifacts share one canonical title without changing metrics or scope.

Co-authored-by: Cursor <cursoragent@cursor.com>
</commit_message>
<xml_diff>
--- a/SecureCoating-Vision_Final_Defense_6min.pptx
+++ b/SecureCoating-Vision_Final_Defense_6min.pptx
@@ -3293,7 +3293,7 @@
                 </a:solidFill>
                 <a:latin typeface="Calibri"/>
               </a:rPr>
-              <a:t>SecureCoating Vision: A High-Throughput and Zero-Trust Edge-Cloud Pipeline for Inline Battery Electrode Defect Inspection and Traceable Quality Decisions</a:t>
+              <a:t>SecureCoating-Vision: Evidence-Gated Multimodal AI for Battery Electrode Inspection and Traceable Quality Decisions</a:t>
             </a:r>
           </a:p>
         </p:txBody>
@@ -3485,7 +3485,7 @@
                 </a:solidFill>
                 <a:latin typeface="Calibri"/>
               </a:rPr>
-              <a:t>Registered title describes the target Zero-Trust Edge-Cloud architecture. This prototype validates inspection, evidence gating, and fail-closed contracts — not completed mTLS/RBAC/OT or factory qualification.</a:t>
+              <a:t>This prototype validates inspection, evidence gating, and fail-closed contracts on real optical and multimodal evidence. Production security hardening such as mTLS, RBAC, secret rotation, and OT segmentation remains part of the industrialization roadmap.</a:t>
             </a:r>
           </a:p>
           <a:p>
@@ -10042,7 +10042,7 @@
                 </a:solidFill>
                 <a:latin typeface="Calibri"/>
               </a:rPr>
-              <a:t>Registered title states the target Zero-Trust Edge-Cloud architecture; this artifact validates inspection, evidence, and fail-closed contracts — not completed mTLS/RBAC/OT. GIFs loop checked-in artifacts. Authors' interim is DINOv2 1-seed, not DINOv3.</a:t>
+              <a:t>This artifact validates inspection, evidence, and fail-closed contracts. Production mTLS/RBAC/OT hardening remains on the industrialization roadmap. GIFs loop checked-in artifacts. Authors' interim is DINOv2 1-seed, not DINOv3.</a:t>
             </a:r>
           </a:p>
         </p:txBody>

</xml_diff>

<commit_message>
Finalize release audit: Application Form roster/date, analysis report, and provenance clarity.
Keep metrics unchanged while separating contestants from advisor, clarifying LIBAD historical evidence, and distinguishing RGB detector inputs from auxiliary adapters.

Co-authored-by: Cursor <cursoragent@cursor.com>
</commit_message>
<xml_diff>
--- a/SecureCoating-Vision_Final_Defense_6min.pptx
+++ b/SecureCoating-Vision_Final_Defense_6min.pptx
@@ -4687,13 +4687,13 @@
               </a:spcAft>
             </a:pPr>
             <a:r>
-              <a:rPr sz="1400" b="0">
+              <a:rPr sz="1300" b="0">
                 <a:solidFill>
                   <a:srgbClr val="5C6775"/>
                 </a:solidFill>
                 <a:latin typeface="Calibri"/>
               </a:rPr>
-              <a:t>Official mount hashed. Local numpy adapter mean multimodal AUROC 0.700 / FPR95 0.839 over 10 official splits — non-paper-comparable. Authors' DINOv2 interim (1 seed) ~AUROC 0.856 / FPR95 0.716; not paper DINOv3/DA-Core. Demo cases stay protocol fixtures.</a:t>
+              <a:t>Archived official-input local adapter: mean multimodal AUROC 0.700 / FPR95 0.839 over 10 official splits — historical evidence, non-paper-comparable. Authors' runner interim historical smoke (1 seed): AUROC ~0.856 / FPR95 ~0.716 — not DINOv3/DA-Core paper reproduction. Demo cases stay protocol fixtures.</a:t>
             </a:r>
           </a:p>
           <a:p>

</xml_diff>

<commit_message>
Record current-HEAD RGB and LIBAD adapter evidence with stage-safe defense framing.
Re-evaluated CoatingVision and the official-input LIBAD local adapter on the framing commit, shortened Slide 3, added buy-path cues, and Challenge-1-safe inspection-to-decision wording.

Co-authored-by: Cursor <cursoragent@cursor.com>
</commit_message>
<xml_diff>
--- a/SecureCoating-Vision_Final_Defense_6min.pptx
+++ b/SecureCoating-Vision_Final_Defense_6min.pptx
@@ -4677,7 +4677,7 @@
                 </a:solidFill>
                 <a:latin typeface="Calibri"/>
               </a:rPr>
-              <a:t>LIBAD VIS + X-rayL local adapter</a:t>
+              <a:t>LIBAD VIS + X-rayL</a:t>
             </a:r>
           </a:p>
           <a:p>
@@ -4687,13 +4687,13 @@
               </a:spcAft>
             </a:pPr>
             <a:r>
-              <a:rPr sz="1300" b="0">
+              <a:rPr sz="1500" b="0">
                 <a:solidFill>
                   <a:srgbClr val="5C6775"/>
                 </a:solidFill>
                 <a:latin typeface="Calibri"/>
               </a:rPr>
-              <a:t>Archived official-input local adapter: mean multimodal AUROC 0.700 / FPR95 0.839 over 10 official splits — historical evidence, non-paper-comparable. Authors' runner interim historical smoke (1 seed): AUROC ~0.856 / FPR95 ~0.716 — not DINOv3/DA-Core paper reproduction. Demo cases stay protocol fixtures.</a:t>
+              <a:t>We extended validation to LIBAD's real aligned VIS and X-rayL data over its 10 official splits. The current adapter is an external validation experiment—not a claim of reproducing the authors' DA-Core paper results.</a:t>
             </a:r>
           </a:p>
           <a:p>
@@ -4709,7 +4709,7 @@
                 </a:solidFill>
                 <a:latin typeface="Calibri"/>
               </a:rPr>
-              <a:t>DA-Core is Sui et al. SecureCoating-Vision adds the evidence gate, not a paper reproduction claim.</a:t>
+              <a:t>Even a stronger anomaly detector still leaves a false-positive operating point unsuitable for direct line authority. That is why detection is separated from disposition.</a:t>
             </a:r>
           </a:p>
         </p:txBody>
@@ -6507,6 +6507,54 @@
             <a:r>
               <a:rPr sz="1200" b="1">
                 <a:solidFill>
+                  <a:srgbClr val="1F5EB8"/>
+                </a:solidFill>
+                <a:latin typeface="Calibri"/>
+              </a:rPr>
+              <a:t>BUY PATH</a:t>
+            </a:r>
+          </a:p>
+          <a:p>
+            <a:pPr algn="l">
+              <a:spcAft>
+                <a:spcPts val="1000"/>
+              </a:spcAft>
+            </a:pPr>
+            <a:r>
+              <a:rPr sz="1400" b="1">
+                <a:solidFill>
+                  <a:srgbClr val="1A1F2B"/>
+                </a:solidFill>
+                <a:latin typeface="Calibri"/>
+              </a:rPr>
+              <a:t>Shadow inspection → PLC/HIL → controlled decision assistance → per-line deployment</a:t>
+            </a:r>
+          </a:p>
+          <a:p>
+            <a:pPr algn="l">
+              <a:spcAft>
+                <a:spcPts val="1400"/>
+              </a:spcAft>
+            </a:pPr>
+            <a:r>
+              <a:rPr sz="1300" b="0">
+                <a:solidFill>
+                  <a:srgbClr val="5C6775"/>
+                </a:solidFill>
+                <a:latin typeface="Calibri"/>
+              </a:rPr>
+              <a:t>Commercial model: per-line integration + calibration, model-monitoring and traceability support.</a:t>
+            </a:r>
+          </a:p>
+          <a:p>
+            <a:pPr algn="l">
+              <a:spcAft>
+                <a:spcPts val="600"/>
+              </a:spcAft>
+            </a:pPr>
+            <a:r>
+              <a:rPr sz="1200" b="1">
+                <a:solidFill>
                   <a:srgbClr val="C8102E"/>
                 </a:solidFill>
                 <a:latin typeface="Calibri"/>
@@ -6517,97 +6565,17 @@
           <a:p>
             <a:pPr algn="l">
               <a:spcAft>
-                <a:spcPts val="400"/>
-              </a:spcAft>
-            </a:pPr>
-            <a:r>
-              <a:rPr sz="1600" b="1">
+                <a:spcPts val="800"/>
+              </a:spcAft>
+            </a:pPr>
+            <a:r>
+              <a:rPr sz="1300" b="0">
                 <a:solidFill>
                   <a:srgbClr val="1A1F2B"/>
                 </a:solidFill>
                 <a:latin typeface="Calibri"/>
               </a:rPr>
-              <a:t>Recipe sliders</a:t>
-            </a:r>
-          </a:p>
-          <a:p>
-            <a:pPr algn="l">
-              <a:spcAft>
-                <a:spcPts val="400"/>
-              </a:spcAft>
-            </a:pPr>
-            <a:r>
-              <a:rPr sz="1600" b="1">
-                <a:solidFill>
-                  <a:srgbClr val="1A1F2B"/>
-                </a:solidFill>
-                <a:latin typeface="Calibri"/>
-              </a:rPr>
-              <a:t>Defect injection</a:t>
-            </a:r>
-          </a:p>
-          <a:p>
-            <a:pPr algn="l">
-              <a:spcAft>
-                <a:spcPts val="400"/>
-              </a:spcAft>
-            </a:pPr>
-            <a:r>
-              <a:rPr sz="1600" b="1">
-                <a:solidFill>
-                  <a:srgbClr val="1A1F2B"/>
-                </a:solidFill>
-                <a:latin typeface="Calibri"/>
-              </a:rPr>
-              <a:t>7-stage simulator</a:t>
-            </a:r>
-          </a:p>
-          <a:p>
-            <a:pPr algn="l">
-              <a:spcAft>
-                <a:spcPts val="400"/>
-              </a:spcAft>
-            </a:pPr>
-            <a:r>
-              <a:rPr sz="1600" b="1">
-                <a:solidFill>
-                  <a:srgbClr val="1A1F2B"/>
-                </a:solidFill>
-                <a:latin typeface="Calibri"/>
-              </a:rPr>
-              <a:t>LIBAD 90s demo</a:t>
-            </a:r>
-          </a:p>
-          <a:p>
-            <a:pPr algn="l">
-              <a:spcAft>
-                <a:spcPts val="1200"/>
-              </a:spcAft>
-            </a:pPr>
-            <a:r>
-              <a:rPr sz="1600" b="1">
-                <a:solidFill>
-                  <a:srgbClr val="1A1F2B"/>
-                </a:solidFill>
-                <a:latin typeface="Calibri"/>
-              </a:rPr>
-              <a:t>Send offset to PLC</a:t>
-            </a:r>
-          </a:p>
-          <a:p>
-            <a:pPr algn="l">
-              <a:spcAft>
-                <a:spcPts val="600"/>
-              </a:spcAft>
-            </a:pPr>
-            <a:r>
-              <a:rPr sz="1300" b="0">
-                <a:solidFill>
-                  <a:srgbClr val="5C6775"/>
-                </a:solidFill>
-                <a:latin typeface="Calibri"/>
-              </a:rPr>
-              <a:t>Sandbox-only features stay isolated from the operating surface.</a:t>
+              <a:t>Recipe / inject / 7-stage sim / LIBAD 90s demo / send offset — sandbox only.</a:t>
             </a:r>
           </a:p>
           <a:p>
@@ -9336,7 +9304,7 @@
                 </a:solidFill>
                 <a:latin typeface="Calibri"/>
               </a:rPr>
-              <a:t>21.6 ms/image  ·  CPU evaluation  ·  model inference only  ·  not factory-line throughput</a:t>
+              <a:t>59.5 ms/image  ·  CPU evaluation  ·  model inference only  ·  not factory-line throughput</a:t>
             </a:r>
           </a:p>
         </p:txBody>
@@ -10016,11 +9984,11 @@
           <a:p>
             <a:pPr algn="l">
               <a:spcAft>
-                <a:spcPts val="800"/>
-              </a:spcAft>
-            </a:pPr>
-            <a:r>
-              <a:rPr sz="1800" b="1">
+                <a:spcPts val="600"/>
+              </a:spcAft>
+            </a:pPr>
+            <a:r>
+              <a:rPr sz="1700" b="1">
                 <a:solidFill>
                   <a:srgbClr val="1A1F2B"/>
                 </a:solidFill>
@@ -10032,6 +10000,22 @@
           <a:p>
             <a:pPr algn="l">
               <a:spcAft>
+                <a:spcPts val="400"/>
+              </a:spcAft>
+            </a:pPr>
+            <a:r>
+              <a:rPr sz="1300" b="0">
+                <a:solidFill>
+                  <a:srgbClr val="5C6775"/>
+                </a:solidFill>
+                <a:latin typeface="Calibri"/>
+              </a:rPr>
+              <a:t>SecureCoating covers the inspection-to-quality-decision segment of an autonomous materials characterization pipeline. Property prediction is the next validation stage once plant-linked labels exist.</a:t>
+            </a:r>
+          </a:p>
+          <a:p>
+            <a:pPr algn="l">
+              <a:spcAft>
                 <a:spcPts val="600"/>
               </a:spcAft>
             </a:pPr>
@@ -10042,7 +10026,7 @@
                 </a:solidFill>
                 <a:latin typeface="Calibri"/>
               </a:rPr>
-              <a:t>This artifact validates inspection, evidence, and fail-closed contracts. Production mTLS/RBAC/OT hardening remains on the industrialization roadmap. GIFs loop checked-in artifacts. Authors' interim is DINOv2 1-seed, not DINOv3.</a:t>
+              <a:t>Buy path: shadow inspection → PLC/HIL → controlled decision assistance → per-line deployment. Production mTLS/RBAC/OT hardening remains on the industrialization roadmap.</a:t>
             </a:r>
           </a:p>
         </p:txBody>

</xml_diff>

<commit_message>
Strip commercial pitch language from the Track 4 defense deck.
Replace BUY PATH / commercial-model wording with deployment roadmap and integration strategy, and surface Team 71 core-engineer capability on the title slide.

Co-authored-by: Cursor <cursoragent@cursor.com>
</commit_message>
<xml_diff>
--- a/SecureCoating-Vision_Final_Defense_6min.pptx
+++ b/SecureCoating-Vision_Final_Defense_6min.pptx
@@ -3389,7 +3389,7 @@
         <p:spPr>
           <a:xfrm>
             <a:off x="411480" y="3520440"/>
-            <a:ext cx="11338560" cy="822960"/>
+            <a:ext cx="11338560" cy="1051560"/>
           </a:xfrm>
           <a:prstGeom prst="rect">
             <a:avLst/>
@@ -3404,33 +3404,49 @@
           <a:p>
             <a:pPr algn="l">
               <a:spcAft>
+                <a:spcPts val="600"/>
+              </a:spcAft>
+            </a:pPr>
+            <a:r>
+              <a:rPr sz="1800" b="1">
+                <a:solidFill>
+                  <a:srgbClr val="1A1F2B"/>
+                </a:solidFill>
+                <a:latin typeface="Calibri"/>
+              </a:rPr>
+              <a:t>Team 71 · Track 4 — AI + Materials Testing &amp; Characterization</a:t>
+            </a:r>
+          </a:p>
+          <a:p>
+            <a:pPr algn="l">
+              <a:spcAft>
+                <a:spcPts val="400"/>
+              </a:spcAft>
+            </a:pPr>
+            <a:r>
+              <a:rPr sz="1800" b="1">
+                <a:solidFill>
+                  <a:srgbClr val="1A1F2B"/>
+                </a:solidFill>
+                <a:latin typeface="Calibri"/>
+              </a:rPr>
+              <a:t>Trinh Hoang Tu · HUFLIT</a:t>
+            </a:r>
+          </a:p>
+          <a:p>
+            <a:pPr algn="l">
+              <a:spcAft>
                 <a:spcPts val="800"/>
               </a:spcAft>
             </a:pPr>
             <a:r>
-              <a:rPr sz="1800" b="1">
-                <a:solidFill>
-                  <a:srgbClr val="1A1F2B"/>
-                </a:solidFill>
-                <a:latin typeface="Calibri"/>
-              </a:rPr>
-              <a:t>Team 71 · Track 4 — AI + Materials Testing &amp; Characterization</a:t>
-            </a:r>
-          </a:p>
-          <a:p>
-            <a:pPr algn="l">
-              <a:spcAft>
-                <a:spcPts val="1000"/>
-              </a:spcAft>
-            </a:pPr>
-            <a:r>
-              <a:rPr sz="1800" b="1">
-                <a:solidFill>
-                  <a:srgbClr val="1A1F2B"/>
-                </a:solidFill>
-                <a:latin typeface="Calibri"/>
-              </a:rPr>
-              <a:t>Trinh Hoang Tu · HUFLIT</a:t>
+              <a:rPr sz="1300" b="0">
+                <a:solidFill>
+                  <a:srgbClr val="1F5EB8"/>
+                </a:solidFill>
+                <a:latin typeface="Calibri"/>
+              </a:rPr>
+              <a:t>Core engineer: system architecture, evidence-gate / PLC contracts, and cybersecurity for the inspection pipeline</a:t>
             </a:r>
           </a:p>
           <a:p>
@@ -6511,7 +6527,7 @@
                 </a:solidFill>
                 <a:latin typeface="Calibri"/>
               </a:rPr>
-              <a:t>BUY PATH</a:t>
+              <a:t>DEPLOYMENT ROADMAP</a:t>
             </a:r>
           </a:p>
           <a:p>
@@ -6543,7 +6559,7 @@
                 </a:solidFill>
                 <a:latin typeface="Calibri"/>
               </a:rPr>
-              <a:t>Commercial model: per-line integration + calibration, model-monitoring and traceability support.</a:t>
+              <a:t>Integration &amp; maintenance strategy: per-line integration + calibration, model monitoring, and traceability support.</a:t>
             </a:r>
           </a:p>
           <a:p>
@@ -10026,7 +10042,7 @@
                 </a:solidFill>
                 <a:latin typeface="Calibri"/>
               </a:rPr>
-              <a:t>Buy path: shadow inspection → PLC/HIL → controlled decision assistance → per-line deployment. Production mTLS/RBAC/OT hardening remains on the industrialization roadmap.</a:t>
+              <a:t>Deployment roadmap: shadow inspection → PLC/HIL → controlled decision assistance → per-line deployment. Production mTLS/RBAC/OT hardening remains on the industrialization roadmap.</a:t>
             </a:r>
           </a:p>
         </p:txBody>

</xml_diff>